<commit_message>
Make the service nomination-only and enlarge all deck typography
- Remove every scout-feature claim: service is candidate nominations
  only. Rework cover tagline, summary cards, solution pillars
  (Quality/Choice/Trust), business flow step 3, screening lead,
  productivity reasons, comparison-table axes, economics note, pricing
  inclusions, launch-partner merit, and closing title accordingly
- Scout-market saturation data stays as problem framing only
- Global 1.15x font scale; taller title block and adjusted panel rules
  so larger text keeps clean spacing

Co-Authored-By: Claude Fable 5 <noreply@anthropic.com>
Claude-Session: https://claude.ai/code/session_017r47q7GrDyBFJYXAQhNwDu
</commit_message>
<xml_diff>
--- a/sales/markgate-agent-deck.pptx
+++ b/sales/markgate-agent-deck.pptx
@@ -3264,7 +3264,7 @@
               </a:lnSpc>
             </a:pPr>
             <a:r>
-              <a:rPr sz="1100" b="0" i="0" spc="400">
+              <a:rPr sz="1260" b="0" i="0" spc="400">
                 <a:solidFill>
                   <a:srgbClr val="D8C08C"/>
                 </a:solidFill>
@@ -3304,7 +3304,7 @@
               </a:lnSpc>
             </a:pPr>
             <a:r>
-              <a:rPr sz="5600" b="0" i="0">
+              <a:rPr sz="6440" b="0" i="0">
                 <a:solidFill>
                   <a:srgbClr val="FFFFFF"/>
                 </a:solidFill>
@@ -3314,7 +3314,7 @@
               <a:t>MarkGate</a:t>
             </a:r>
             <a:r>
-              <a:rPr sz="5600" b="0" i="0">
+              <a:rPr sz="6440" b="0" i="0">
                 <a:solidFill>
                   <a:srgbClr val="B8934E"/>
                 </a:solidFill>
@@ -3354,14 +3354,14 @@
               </a:lnSpc>
             </a:pPr>
             <a:r>
-              <a:rPr sz="1750" b="1" i="0" spc="200">
+              <a:rPr sz="2010" b="1" i="0" spc="200">
                 <a:solidFill>
                   <a:srgbClr val="FFFFFF"/>
                 </a:solidFill>
                 <a:latin typeface="Garamond"/>
                 <a:ea typeface="游明朝"/>
               </a:rPr>
-              <a:t>絞るから、届く。スカウトと指名のハイクラス転職。</a:t>
+              <a:t>選ばれるから、届く。“指名”で始まるハイクラス転職。</a:t>
             </a:r>
           </a:p>
         </p:txBody>
@@ -3394,14 +3394,14 @@
               </a:lnSpc>
             </a:pPr>
             <a:r>
-              <a:rPr sz="950" b="0" i="0" spc="100">
+              <a:rPr sz="1090" b="0" i="0" spc="100">
                 <a:solidFill>
                   <a:srgbClr val="ABA595"/>
                 </a:solidFill>
                 <a:latin typeface="Yu Gothic"/>
                 <a:ea typeface="游ゴシック"/>
               </a:rPr>
-              <a:t>「量の競争」で飽和した転職スカウト市場を、送り手を絞る「質の競争」へ。</a:t>
+              <a:t>「量の競争」で飽和した転職スカウト市場に、求職者がCAを選ぶ「指名」という新しい入口を。</a:t>
             </a:r>
           </a:p>
           <a:p>
@@ -3411,7 +3411,7 @@
               </a:lnSpc>
             </a:pPr>
             <a:r>
-              <a:rPr sz="950" b="0" i="0" spc="100">
+              <a:rPr sz="1090" b="0" i="0" spc="100">
                 <a:solidFill>
                   <a:srgbClr val="ABA595"/>
                 </a:solidFill>
@@ -3451,7 +3451,7 @@
               </a:lnSpc>
             </a:pPr>
             <a:r>
-              <a:rPr sz="800" b="0" i="0" spc="300">
+              <a:rPr sz="919" b="0" i="0" spc="300">
                 <a:solidFill>
                   <a:srgbClr val="7E7868"/>
                 </a:solidFill>
@@ -3491,7 +3491,7 @@
               </a:lnSpc>
             </a:pPr>
             <a:r>
-              <a:rPr sz="1050" b="0" i="1">
+              <a:rPr sz="1210" b="0" i="1">
                 <a:solidFill>
                   <a:srgbClr val="D8C08C"/>
                 </a:solidFill>
@@ -3593,7 +3593,7 @@
               </a:lnSpc>
             </a:pPr>
             <a:r>
-              <a:rPr sz="1050" b="0" i="1" spc="250">
+              <a:rPr sz="1210" b="0" i="1" spc="250">
                 <a:solidFill>
                   <a:srgbClr val="8A6A32"/>
                 </a:solidFill>
@@ -3658,7 +3658,7 @@
         <p:spPr>
           <a:xfrm>
             <a:off x="738000" y="1008000"/>
-            <a:ext cx="10713600" cy="576000"/>
+            <a:ext cx="10713600" cy="666000"/>
           </a:xfrm>
           <a:prstGeom prst="rect">
             <a:avLst/>
@@ -3677,7 +3677,7 @@
               </a:lnSpc>
             </a:pPr>
             <a:r>
-              <a:rPr sz="2900" b="1" i="0" spc="100">
+              <a:rPr sz="3329" b="1" i="0" spc="100">
                 <a:solidFill>
                   <a:srgbClr val="201C15"/>
                 </a:solidFill>
@@ -3687,7 +3687,7 @@
               <a:t>母集団は、「CAを</a:t>
             </a:r>
             <a:r>
-              <a:rPr sz="2900" b="1" i="0" spc="100">
+              <a:rPr sz="3329" b="1" i="0" spc="100">
                 <a:solidFill>
                   <a:srgbClr val="B8934E"/>
                 </a:solidFill>
@@ -3697,7 +3697,7 @@
               <a:t>選びたい人</a:t>
             </a:r>
             <a:r>
-              <a:rPr sz="2900" b="1" i="0" spc="100">
+              <a:rPr sz="3329" b="1" i="0" spc="100">
                 <a:solidFill>
                   <a:srgbClr val="201C15"/>
                 </a:solidFill>
@@ -3717,7 +3717,7 @@
         </p:nvSpPr>
         <p:spPr>
           <a:xfrm>
-            <a:off x="738000" y="1602000"/>
+            <a:off x="738000" y="1692000"/>
             <a:ext cx="10713600" cy="324000"/>
           </a:xfrm>
           <a:prstGeom prst="rect">
@@ -3737,7 +3737,7 @@
               </a:lnSpc>
             </a:pPr>
             <a:r>
-              <a:rPr sz="1050" b="0" i="0" spc="100">
+              <a:rPr sz="1210" b="0" i="0" spc="100">
                 <a:solidFill>
                   <a:srgbClr val="8F8A7B"/>
                 </a:solidFill>
@@ -3821,7 +3821,7 @@
               </a:lnSpc>
             </a:pPr>
             <a:r>
-              <a:rPr sz="1200" b="1" i="0">
+              <a:rPr sz="1380" b="1" i="0">
                 <a:solidFill>
                   <a:srgbClr val="201C15"/>
                 </a:solidFill>
@@ -3861,7 +3861,7 @@
               </a:lnSpc>
             </a:pPr>
             <a:r>
-              <a:rPr sz="850" b="0" i="0">
+              <a:rPr sz="980" b="0" i="0">
                 <a:solidFill>
                   <a:srgbClr val="201C15"/>
                 </a:solidFill>
@@ -3945,7 +3945,7 @@
               </a:lnSpc>
             </a:pPr>
             <a:r>
-              <a:rPr sz="1200" b="1" i="0">
+              <a:rPr sz="1380" b="1" i="0">
                 <a:solidFill>
                   <a:srgbClr val="201C15"/>
                 </a:solidFill>
@@ -3985,7 +3985,7 @@
               </a:lnSpc>
             </a:pPr>
             <a:r>
-              <a:rPr sz="850" b="0" i="0">
+              <a:rPr sz="980" b="0" i="0">
                 <a:solidFill>
                   <a:srgbClr val="201C15"/>
                 </a:solidFill>
@@ -4069,7 +4069,7 @@
               </a:lnSpc>
             </a:pPr>
             <a:r>
-              <a:rPr sz="1200" b="1" i="0">
+              <a:rPr sz="1380" b="1" i="0">
                 <a:solidFill>
                   <a:srgbClr val="201C15"/>
                 </a:solidFill>
@@ -4109,7 +4109,7 @@
               </a:lnSpc>
             </a:pPr>
             <a:r>
-              <a:rPr sz="850" b="0" i="0">
+              <a:rPr sz="980" b="0" i="0">
                 <a:solidFill>
                   <a:srgbClr val="201C15"/>
                 </a:solidFill>
@@ -4196,7 +4196,7 @@
               </a:spcAft>
             </a:pPr>
             <a:r>
-              <a:rPr sz="1500" b="0" i="1">
+              <a:rPr sz="1720" b="0" i="1">
                 <a:solidFill>
                   <a:srgbClr val="D8C08C"/>
                 </a:solidFill>
@@ -4216,7 +4216,7 @@
               </a:spcAft>
             </a:pPr>
             <a:r>
-              <a:rPr sz="1050" b="1" i="0">
+              <a:rPr sz="1210" b="1" i="0">
                 <a:solidFill>
                   <a:srgbClr val="FFFFFF"/>
                 </a:solidFill>
@@ -4233,7 +4233,7 @@
               </a:lnSpc>
             </a:pPr>
             <a:r>
-              <a:rPr sz="880" b="0" i="0">
+              <a:rPr sz="1010" b="0" i="0">
                 <a:solidFill>
                   <a:srgbClr val="ABA595"/>
                 </a:solidFill>
@@ -4317,7 +4317,7 @@
               </a:lnSpc>
             </a:pPr>
             <a:r>
-              <a:rPr sz="880" b="0" i="0">
+              <a:rPr sz="1010" b="0" i="0">
                 <a:solidFill>
                   <a:srgbClr val="FFFFFF"/>
                 </a:solidFill>
@@ -4401,7 +4401,7 @@
               </a:lnSpc>
             </a:pPr>
             <a:r>
-              <a:rPr sz="1050" b="0" i="0">
+              <a:rPr sz="1210" b="0" i="0">
                 <a:solidFill>
                   <a:srgbClr val="FFFFFF"/>
                 </a:solidFill>
@@ -4411,7 +4411,7 @@
               <a:t>求職者が集まらなければ、当社の売上もゼロ — </a:t>
             </a:r>
             <a:r>
-              <a:rPr sz="1050" b="1" i="0">
+              <a:rPr sz="1210" b="1" i="0">
                 <a:solidFill>
                   <a:srgbClr val="D8C08C"/>
                 </a:solidFill>
@@ -4513,7 +4513,7 @@
               </a:lnSpc>
             </a:pPr>
             <a:r>
-              <a:rPr sz="1050" b="0" i="1" spc="250">
+              <a:rPr sz="1210" b="0" i="1" spc="250">
                 <a:solidFill>
                   <a:srgbClr val="8A6A32"/>
                 </a:solidFill>
@@ -4578,7 +4578,7 @@
         <p:spPr>
           <a:xfrm>
             <a:off x="738000" y="1008000"/>
-            <a:ext cx="10713600" cy="576000"/>
+            <a:ext cx="10713600" cy="666000"/>
           </a:xfrm>
           <a:prstGeom prst="rect">
             <a:avLst/>
@@ -4597,7 +4597,7 @@
               </a:lnSpc>
             </a:pPr>
             <a:r>
-              <a:rPr sz="2900" b="1" i="0" spc="100">
+              <a:rPr sz="3329" b="1" i="0" spc="100">
                 <a:solidFill>
                   <a:srgbClr val="201C15"/>
                 </a:solidFill>
@@ -4607,7 +4607,7 @@
               <a:t>既存チャネルとの、</a:t>
             </a:r>
             <a:r>
-              <a:rPr sz="2900" b="1" i="0" spc="100">
+              <a:rPr sz="3329" b="1" i="0" spc="100">
                 <a:solidFill>
                   <a:srgbClr val="B8934E"/>
                 </a:solidFill>
@@ -4617,7 +4617,7 @@
               <a:t>違い</a:t>
             </a:r>
             <a:r>
-              <a:rPr sz="2900" b="1" i="0" spc="100">
+              <a:rPr sz="3329" b="1" i="0" spc="100">
                 <a:solidFill>
                   <a:srgbClr val="201C15"/>
                 </a:solidFill>
@@ -4637,7 +4637,7 @@
         </p:nvSpPr>
         <p:spPr>
           <a:xfrm>
-            <a:off x="738000" y="1602000"/>
+            <a:off x="738000" y="1692000"/>
             <a:ext cx="10713600" cy="324000"/>
           </a:xfrm>
           <a:prstGeom prst="rect">
@@ -4657,7 +4657,7 @@
               </a:lnSpc>
             </a:pPr>
             <a:r>
-              <a:rPr sz="1050" b="0" i="0" spc="100">
+              <a:rPr sz="1210" b="0" i="0" spc="100">
                 <a:solidFill>
                   <a:srgbClr val="8F8A7B"/>
                 </a:solidFill>
@@ -4785,7 +4785,7 @@
               </a:lnSpc>
             </a:pPr>
             <a:r>
-              <a:rPr sz="1000" b="1" i="0">
+              <a:rPr sz="1150" b="1" i="0">
                 <a:solidFill>
                   <a:srgbClr val="201C15"/>
                 </a:solidFill>
@@ -4825,7 +4825,7 @@
               </a:lnSpc>
             </a:pPr>
             <a:r>
-              <a:rPr sz="1000" b="1" i="0">
+              <a:rPr sz="1150" b="1" i="0">
                 <a:solidFill>
                   <a:srgbClr val="201C15"/>
                 </a:solidFill>
@@ -4842,7 +4842,7 @@
               </a:lnSpc>
             </a:pPr>
             <a:r>
-              <a:rPr sz="680" b="0" i="0" spc="100">
+              <a:rPr sz="780" b="0" i="0" spc="100">
                 <a:solidFill>
                   <a:srgbClr val="8F8A7B"/>
                 </a:solidFill>
@@ -4882,7 +4882,7 @@
               </a:lnSpc>
             </a:pPr>
             <a:r>
-              <a:rPr sz="1000" b="1" i="0">
+              <a:rPr sz="1150" b="1" i="0">
                 <a:solidFill>
                   <a:srgbClr val="201C15"/>
                 </a:solidFill>
@@ -4899,7 +4899,7 @@
               </a:lnSpc>
             </a:pPr>
             <a:r>
-              <a:rPr sz="680" b="0" i="0" spc="100">
+              <a:rPr sz="780" b="0" i="0" spc="100">
                 <a:solidFill>
                   <a:srgbClr val="8F8A7B"/>
                 </a:solidFill>
@@ -4939,7 +4939,7 @@
               </a:lnSpc>
             </a:pPr>
             <a:r>
-              <a:rPr sz="1000" b="1" i="0">
+              <a:rPr sz="1150" b="1" i="0">
                 <a:solidFill>
                   <a:srgbClr val="FFFFFF"/>
                 </a:solidFill>
@@ -4956,14 +4956,14 @@
               </a:lnSpc>
             </a:pPr>
             <a:r>
-              <a:rPr sz="680" b="0" i="0" spc="100">
+              <a:rPr sz="780" b="0" i="0" spc="100">
                 <a:solidFill>
                   <a:srgbClr val="D8C08C"/>
                 </a:solidFill>
                 <a:latin typeface="Yu Gothic"/>
                 <a:ea typeface="游ゴシック"/>
               </a:rPr>
-              <a:t>審査制×双方向マッチング</a:t>
+              <a:t>審査制×指名型マッチング</a:t>
             </a:r>
           </a:p>
         </p:txBody>
@@ -5084,14 +5084,14 @@
               </a:lnSpc>
             </a:pPr>
             <a:r>
-              <a:rPr sz="900" b="1" i="0">
+              <a:rPr sz="1030" b="1" i="0">
                 <a:solidFill>
                   <a:srgbClr val="201C15"/>
                 </a:solidFill>
                 <a:latin typeface="Yu Gothic"/>
                 <a:ea typeface="游ゴシック"/>
               </a:rPr>
-              <a:t>スカウトの競争環境</a:t>
+              <a:t>求職者との接点</a:t>
             </a:r>
           </a:p>
         </p:txBody>
@@ -5124,7 +5124,7 @@
               </a:lnSpc>
             </a:pPr>
             <a:r>
-              <a:rPr sz="900" b="1" i="0">
+              <a:rPr sz="1030" b="1" i="0">
                 <a:solidFill>
                   <a:srgbClr val="A03A2A"/>
                 </a:solidFill>
@@ -5134,14 +5134,14 @@
               <a:t>✕ </a:t>
             </a:r>
             <a:r>
-              <a:rPr sz="880" b="0" i="0">
+              <a:rPr sz="1010" b="0" i="0">
                 <a:solidFill>
                   <a:srgbClr val="201C15"/>
                 </a:solidFill>
                 <a:latin typeface="Yu Gothic"/>
                 <a:ea typeface="游ゴシック"/>
               </a:rPr>
-              <a:t>誰でも登録可。送信過多で受信箱が飽和</a:t>
+              <a:t>スカウト送信（受信箱で競争・埋もれる）</a:t>
             </a:r>
           </a:p>
         </p:txBody>
@@ -5174,24 +5174,24 @@
               </a:lnSpc>
             </a:pPr>
             <a:r>
-              <a:rPr sz="900" b="1" i="0">
+              <a:rPr sz="1030" b="1" i="0">
                 <a:solidFill>
                   <a:srgbClr val="8F8A7B"/>
                 </a:solidFill>
                 <a:latin typeface="Yu Gothic"/>
                 <a:ea typeface="游ゴシック"/>
               </a:rPr>
-              <a:t>— </a:t>
-            </a:r>
-            <a:r>
-              <a:rPr sz="880" b="0" i="0">
+              <a:t>△ </a:t>
+            </a:r>
+            <a:r>
+              <a:rPr sz="1010" b="0" i="0">
                 <a:solidFill>
                   <a:srgbClr val="201C15"/>
                 </a:solidFill>
                 <a:latin typeface="Yu Gothic"/>
                 <a:ea typeface="游ゴシック"/>
               </a:rPr>
-              <a:t>スカウト機能なし</a:t>
+              <a:t>面談リストの購入</a:t>
             </a:r>
           </a:p>
         </p:txBody>
@@ -5224,7 +5224,7 @@
               </a:lnSpc>
             </a:pPr>
             <a:r>
-              <a:rPr sz="900" b="1" i="0">
+              <a:rPr sz="1030" b="1" i="0">
                 <a:solidFill>
                   <a:srgbClr val="D8C08C"/>
                 </a:solidFill>
@@ -5234,14 +5234,14 @@
               <a:t>◎ </a:t>
             </a:r>
             <a:r>
-              <a:rPr sz="880" b="0" i="0">
+              <a:rPr sz="1010" b="0" i="0">
                 <a:solidFill>
                   <a:srgbClr val="FFFFFF"/>
                 </a:solidFill>
                 <a:latin typeface="Yu Gothic"/>
                 <a:ea typeface="游ゴシック"/>
               </a:rPr>
-              <a:t>審査制で送り手を限定</a:t>
+              <a:t>求職者からの「指名」が届く</a:t>
             </a:r>
           </a:p>
         </p:txBody>
@@ -5362,14 +5362,14 @@
               </a:lnSpc>
             </a:pPr>
             <a:r>
-              <a:rPr sz="900" b="1" i="0">
+              <a:rPr sz="1030" b="1" i="0">
                 <a:solidFill>
                   <a:srgbClr val="201C15"/>
                 </a:solidFill>
                 <a:latin typeface="Yu Gothic"/>
                 <a:ea typeface="游ゴシック"/>
               </a:rPr>
-              <a:t>求職者からの指名</a:t>
+              <a:t>担当者を選べるか</a:t>
             </a:r>
           </a:p>
         </p:txBody>
@@ -5402,7 +5402,7 @@
               </a:lnSpc>
             </a:pPr>
             <a:r>
-              <a:rPr sz="900" b="1" i="0">
+              <a:rPr sz="1030" b="1" i="0">
                 <a:solidFill>
                   <a:srgbClr val="A03A2A"/>
                 </a:solidFill>
@@ -5412,14 +5412,14 @@
               <a:t>✕ </a:t>
             </a:r>
             <a:r>
-              <a:rPr sz="880" b="0" i="0">
+              <a:rPr sz="1010" b="0" i="0">
                 <a:solidFill>
                   <a:srgbClr val="201C15"/>
                 </a:solidFill>
                 <a:latin typeface="Yu Gothic"/>
                 <a:ea typeface="游ゴシック"/>
               </a:rPr>
-              <a:t>不可</a:t>
+              <a:t>選べない</a:t>
             </a:r>
           </a:p>
         </p:txBody>
@@ -5452,7 +5452,7 @@
               </a:lnSpc>
             </a:pPr>
             <a:r>
-              <a:rPr sz="900" b="1" i="0">
+              <a:rPr sz="1030" b="1" i="0">
                 <a:solidFill>
                   <a:srgbClr val="A03A2A"/>
                 </a:solidFill>
@@ -5462,14 +5462,14 @@
               <a:t>✕ </a:t>
             </a:r>
             <a:r>
-              <a:rPr sz="880" b="0" i="0">
+              <a:rPr sz="1010" b="0" i="0">
                 <a:solidFill>
                   <a:srgbClr val="201C15"/>
                 </a:solidFill>
                 <a:latin typeface="Yu Gothic"/>
                 <a:ea typeface="游ゴシック"/>
               </a:rPr>
-              <a:t>不可</a:t>
+              <a:t>選べない</a:t>
             </a:r>
           </a:p>
         </p:txBody>
@@ -5502,7 +5502,7 @@
               </a:lnSpc>
             </a:pPr>
             <a:r>
-              <a:rPr sz="900" b="1" i="0">
+              <a:rPr sz="1030" b="1" i="0">
                 <a:solidFill>
                   <a:srgbClr val="D8C08C"/>
                 </a:solidFill>
@@ -5512,14 +5512,14 @@
               <a:t>◎ </a:t>
             </a:r>
             <a:r>
-              <a:rPr sz="880" b="0" i="0">
+              <a:rPr sz="1010" b="0" i="0">
                 <a:solidFill>
                   <a:srgbClr val="FFFFFF"/>
                 </a:solidFill>
                 <a:latin typeface="Yu Gothic"/>
                 <a:ea typeface="游ゴシック"/>
               </a:rPr>
-              <a:t>指名が届く</a:t>
+              <a:t>求職者がCAを選んで指名</a:t>
             </a:r>
           </a:p>
         </p:txBody>
@@ -5640,7 +5640,7 @@
               </a:lnSpc>
             </a:pPr>
             <a:r>
-              <a:rPr sz="900" b="1" i="0">
+              <a:rPr sz="1030" b="1" i="0">
                 <a:solidFill>
                   <a:srgbClr val="201C15"/>
                 </a:solidFill>
@@ -5680,7 +5680,7 @@
               </a:lnSpc>
             </a:pPr>
             <a:r>
-              <a:rPr sz="900" b="1" i="0">
+              <a:rPr sz="1030" b="1" i="0">
                 <a:solidFill>
                   <a:srgbClr val="A03A2A"/>
                 </a:solidFill>
@@ -5690,7 +5690,7 @@
               <a:t>✕ </a:t>
             </a:r>
             <a:r>
-              <a:rPr sz="880" b="0" i="0">
+              <a:rPr sz="1010" b="0" i="0">
                 <a:solidFill>
                   <a:srgbClr val="201C15"/>
                 </a:solidFill>
@@ -5730,7 +5730,7 @@
               </a:lnSpc>
             </a:pPr>
             <a:r>
-              <a:rPr sz="900" b="1" i="0">
+              <a:rPr sz="1030" b="1" i="0">
                 <a:solidFill>
                   <a:srgbClr val="A03A2A"/>
                 </a:solidFill>
@@ -5740,7 +5740,7 @@
               <a:t>✕ </a:t>
             </a:r>
             <a:r>
-              <a:rPr sz="880" b="0" i="0">
+              <a:rPr sz="1010" b="0" i="0">
                 <a:solidFill>
                   <a:srgbClr val="201C15"/>
                 </a:solidFill>
@@ -5780,7 +5780,7 @@
               </a:lnSpc>
             </a:pPr>
             <a:r>
-              <a:rPr sz="900" b="1" i="0">
+              <a:rPr sz="1030" b="1" i="0">
                 <a:solidFill>
                   <a:srgbClr val="D8C08C"/>
                 </a:solidFill>
@@ -5790,7 +5790,7 @@
               <a:t>◎ </a:t>
             </a:r>
             <a:r>
-              <a:rPr sz="880" b="0" i="0">
+              <a:rPr sz="1010" b="0" i="0">
                 <a:solidFill>
                   <a:srgbClr val="FFFFFF"/>
                 </a:solidFill>
@@ -5918,7 +5918,7 @@
               </a:lnSpc>
             </a:pPr>
             <a:r>
-              <a:rPr sz="900" b="1" i="0">
+              <a:rPr sz="1030" b="1" i="0">
                 <a:solidFill>
                   <a:srgbClr val="201C15"/>
                 </a:solidFill>
@@ -5958,7 +5958,7 @@
               </a:lnSpc>
             </a:pPr>
             <a:r>
-              <a:rPr sz="900" b="1" i="0">
+              <a:rPr sz="1030" b="1" i="0">
                 <a:solidFill>
                   <a:srgbClr val="A03A2A"/>
                 </a:solidFill>
@@ -5968,7 +5968,7 @@
               <a:t>✕ </a:t>
             </a:r>
             <a:r>
-              <a:rPr sz="880" b="0" i="0">
+              <a:rPr sz="1010" b="0" i="0">
                 <a:solidFill>
                   <a:srgbClr val="201C15"/>
                 </a:solidFill>
@@ -6008,7 +6008,7 @@
               </a:lnSpc>
             </a:pPr>
             <a:r>
-              <a:rPr sz="900" b="1" i="0">
+              <a:rPr sz="1030" b="1" i="0">
                 <a:solidFill>
                   <a:srgbClr val="8F8A7B"/>
                 </a:solidFill>
@@ -6018,7 +6018,7 @@
               <a:t>△ </a:t>
             </a:r>
             <a:r>
-              <a:rPr sz="880" b="0" i="0">
+              <a:rPr sz="1010" b="0" i="0">
                 <a:solidFill>
                   <a:srgbClr val="201C15"/>
                 </a:solidFill>
@@ -6058,7 +6058,7 @@
               </a:lnSpc>
             </a:pPr>
             <a:r>
-              <a:rPr sz="900" b="1" i="0">
+              <a:rPr sz="1030" b="1" i="0">
                 <a:solidFill>
                   <a:srgbClr val="D8C08C"/>
                 </a:solidFill>
@@ -6068,7 +6068,7 @@
               <a:t>◎ </a:t>
             </a:r>
             <a:r>
-              <a:rPr sz="880" b="0" i="0">
+              <a:rPr sz="1010" b="0" i="0">
                 <a:solidFill>
                   <a:srgbClr val="FFFFFF"/>
                 </a:solidFill>
@@ -6108,7 +6108,7 @@
               </a:lnSpc>
             </a:pPr>
             <a:r>
-              <a:rPr sz="700" b="0" i="0">
+              <a:rPr sz="800" b="0" i="0">
                 <a:solidFill>
                   <a:srgbClr val="8F8A7B"/>
                 </a:solidFill>
@@ -6210,7 +6210,7 @@
               </a:lnSpc>
             </a:pPr>
             <a:r>
-              <a:rPr sz="1050" b="0" i="1" spc="250">
+              <a:rPr sz="1210" b="0" i="1" spc="250">
                 <a:solidFill>
                   <a:srgbClr val="8A6A32"/>
                 </a:solidFill>
@@ -6275,7 +6275,7 @@
         <p:spPr>
           <a:xfrm>
             <a:off x="738000" y="1008000"/>
-            <a:ext cx="10713600" cy="576000"/>
+            <a:ext cx="10713600" cy="666000"/>
           </a:xfrm>
           <a:prstGeom prst="rect">
             <a:avLst/>
@@ -6294,7 +6294,7 @@
               </a:lnSpc>
             </a:pPr>
             <a:r>
-              <a:rPr sz="2900" b="1" i="0" spc="100">
+              <a:rPr sz="3329" b="1" i="0" spc="100">
                 <a:solidFill>
                   <a:srgbClr val="201C15"/>
                 </a:solidFill>
@@ -6304,7 +6304,7 @@
               <a:t>同じ1成約で、</a:t>
             </a:r>
             <a:r>
-              <a:rPr sz="2900" b="1" i="0" spc="100">
+              <a:rPr sz="3329" b="1" i="0" spc="100">
                 <a:solidFill>
                   <a:srgbClr val="B8934E"/>
                 </a:solidFill>
@@ -6314,7 +6314,7 @@
               <a:t>手残り</a:t>
             </a:r>
             <a:r>
-              <a:rPr sz="2900" b="1" i="0" spc="100">
+              <a:rPr sz="3329" b="1" i="0" spc="100">
                 <a:solidFill>
                   <a:srgbClr val="201C15"/>
                 </a:solidFill>
@@ -6334,7 +6334,7 @@
         </p:nvSpPr>
         <p:spPr>
           <a:xfrm>
-            <a:off x="738000" y="1602000"/>
+            <a:off x="738000" y="1692000"/>
             <a:ext cx="10713600" cy="324000"/>
           </a:xfrm>
           <a:prstGeom prst="rect">
@@ -6354,7 +6354,7 @@
               </a:lnSpc>
             </a:pPr>
             <a:r>
-              <a:rPr sz="1050" b="0" i="0" spc="100">
+              <a:rPr sz="1210" b="0" i="0" spc="100">
                 <a:solidFill>
                   <a:srgbClr val="8F8A7B"/>
                 </a:solidFill>
@@ -6397,7 +6397,7 @@
               </a:spcAft>
             </a:pPr>
             <a:r>
-              <a:rPr sz="750" b="0" i="0">
+              <a:rPr sz="860" b="0" i="0">
                 <a:solidFill>
                   <a:srgbClr val="8F8A7B"/>
                 </a:solidFill>
@@ -6414,7 +6414,7 @@
               </a:lnSpc>
             </a:pPr>
             <a:r>
-              <a:rPr sz="3000" b="0" i="0">
+              <a:rPr sz="3450" b="0" i="0">
                 <a:solidFill>
                   <a:srgbClr val="201C15"/>
                 </a:solidFill>
@@ -6424,7 +6424,7 @@
               <a:t>600</a:t>
             </a:r>
             <a:r>
-              <a:rPr sz="1200" b="1" i="0">
+              <a:rPr sz="1380" b="1" i="0">
                 <a:solidFill>
                   <a:srgbClr val="201C15"/>
                 </a:solidFill>
@@ -6464,7 +6464,7 @@
               </a:lnSpc>
             </a:pPr>
             <a:r>
-              <a:rPr sz="1300" b="0" i="0">
+              <a:rPr sz="1490" b="0" i="0">
                 <a:solidFill>
                   <a:srgbClr val="8F8A7B"/>
                 </a:solidFill>
@@ -6507,7 +6507,7 @@
               </a:spcAft>
             </a:pPr>
             <a:r>
-              <a:rPr sz="750" b="0" i="0">
+              <a:rPr sz="860" b="0" i="0">
                 <a:solidFill>
                   <a:srgbClr val="8F8A7B"/>
                 </a:solidFill>
@@ -6524,7 +6524,7 @@
               </a:lnSpc>
             </a:pPr>
             <a:r>
-              <a:rPr sz="3000" b="0" i="0">
+              <a:rPr sz="3450" b="0" i="0">
                 <a:solidFill>
                   <a:srgbClr val="201C15"/>
                 </a:solidFill>
@@ -6534,7 +6534,7 @@
               <a:t>35</a:t>
             </a:r>
             <a:r>
-              <a:rPr sz="1200" b="1" i="0">
+              <a:rPr sz="1380" b="1" i="0">
                 <a:solidFill>
                   <a:srgbClr val="201C15"/>
                 </a:solidFill>
@@ -6574,7 +6574,7 @@
               </a:lnSpc>
             </a:pPr>
             <a:r>
-              <a:rPr sz="1300" b="0" i="0">
+              <a:rPr sz="1490" b="0" i="0">
                 <a:solidFill>
                   <a:srgbClr val="8F8A7B"/>
                 </a:solidFill>
@@ -6661,7 +6661,7 @@
               </a:spcAft>
             </a:pPr>
             <a:r>
-              <a:rPr sz="750" b="0" i="0">
+              <a:rPr sz="860" b="0" i="0">
                 <a:solidFill>
                   <a:srgbClr val="D8C08C"/>
                 </a:solidFill>
@@ -6678,7 +6678,7 @@
               </a:lnSpc>
             </a:pPr>
             <a:r>
-              <a:rPr sz="2700" b="0" i="0">
+              <a:rPr sz="3100" b="0" i="0">
                 <a:solidFill>
                   <a:srgbClr val="FFFFFF"/>
                 </a:solidFill>
@@ -6688,7 +6688,7 @@
               <a:t>210</a:t>
             </a:r>
             <a:r>
-              <a:rPr sz="1200" b="1" i="0">
+              <a:rPr sz="1380" b="1" i="0">
                 <a:solidFill>
                   <a:srgbClr val="FFFFFF"/>
                 </a:solidFill>
@@ -6728,7 +6728,7 @@
               </a:lnSpc>
             </a:pPr>
             <a:r>
-              <a:rPr sz="750" b="0" i="0" spc="100">
+              <a:rPr sz="860" b="0" i="0" spc="100">
                 <a:solidFill>
                   <a:srgbClr val="8F8A7B"/>
                 </a:solidFill>
@@ -6856,7 +6856,7 @@
               </a:lnSpc>
             </a:pPr>
             <a:r>
-              <a:rPr sz="1100" b="1" i="0">
+              <a:rPr sz="1260" b="1" i="0">
                 <a:solidFill>
                   <a:srgbClr val="FFFFFF"/>
                 </a:solidFill>
@@ -6896,7 +6896,7 @@
               </a:lnSpc>
             </a:pPr>
             <a:r>
-              <a:rPr sz="1000" b="1" i="0">
+              <a:rPr sz="1150" b="1" i="0">
                 <a:solidFill>
                   <a:srgbClr val="131009"/>
                 </a:solidFill>
@@ -6936,7 +6936,7 @@
               </a:lnSpc>
             </a:pPr>
             <a:r>
-              <a:rPr sz="730" b="0" i="0">
+              <a:rPr sz="840" b="0" i="0">
                 <a:solidFill>
                   <a:srgbClr val="8F8A7B"/>
                 </a:solidFill>
@@ -6976,7 +6976,7 @@
               </a:lnSpc>
             </a:pPr>
             <a:r>
-              <a:rPr sz="900" b="1" i="0">
+              <a:rPr sz="1030" b="1" i="0">
                 <a:solidFill>
                   <a:srgbClr val="201C15"/>
                 </a:solidFill>
@@ -6986,7 +6986,7 @@
               <a:t>スカウト型DB経由の一例: </a:t>
             </a:r>
             <a:r>
-              <a:rPr sz="900" b="0" i="0">
+              <a:rPr sz="1030" b="0" i="0">
                 <a:solidFill>
                   <a:srgbClr val="201C15"/>
                 </a:solidFill>
@@ -7070,7 +7070,7 @@
               </a:lnSpc>
             </a:pPr>
             <a:r>
-              <a:rPr sz="950" b="1" i="0">
+              <a:rPr sz="1090" b="1" i="0">
                 <a:solidFill>
                   <a:srgbClr val="D8C08C"/>
                 </a:solidFill>
@@ -7080,14 +7080,14 @@
               <a:t>MarkGate: </a:t>
             </a:r>
             <a:r>
-              <a:rPr sz="950" b="1" i="0">
+              <a:rPr sz="1090" b="1" i="0">
                 <a:solidFill>
                   <a:srgbClr val="FFFFFF"/>
                 </a:solidFill>
                 <a:latin typeface="Yu Gothic"/>
                 <a:ea typeface="游ゴシック"/>
               </a:rPr>
-              <a:t>成約まで0円。スカウト工数の削減まで含めて、利益率が変わる。</a:t>
+              <a:t>成約まで0円。“送る工数”がないことまで含めて、利益率が変わる。</a:t>
             </a:r>
           </a:p>
         </p:txBody>
@@ -7120,7 +7120,7 @@
               </a:lnSpc>
             </a:pPr>
             <a:r>
-              <a:rPr sz="700" b="0" i="0">
+              <a:rPr sz="800" b="0" i="0">
                 <a:solidFill>
                   <a:srgbClr val="8F8A7B"/>
                 </a:solidFill>
@@ -7222,7 +7222,7 @@
               </a:lnSpc>
             </a:pPr>
             <a:r>
-              <a:rPr sz="1050" b="0" i="1" spc="250">
+              <a:rPr sz="1210" b="0" i="1" spc="250">
                 <a:solidFill>
                   <a:srgbClr val="8A6A32"/>
                 </a:solidFill>
@@ -7287,7 +7287,7 @@
         <p:spPr>
           <a:xfrm>
             <a:off x="738000" y="1008000"/>
-            <a:ext cx="10713600" cy="576000"/>
+            <a:ext cx="10713600" cy="666000"/>
           </a:xfrm>
           <a:prstGeom prst="rect">
             <a:avLst/>
@@ -7306,7 +7306,7 @@
               </a:lnSpc>
             </a:pPr>
             <a:r>
-              <a:rPr sz="2900" b="1" i="0" spc="100">
+              <a:rPr sz="3329" b="1" i="0" spc="100">
                 <a:solidFill>
                   <a:srgbClr val="201C15"/>
                 </a:solidFill>
@@ -7316,7 +7316,7 @@
               <a:t>「審査制」は、貴社の</a:t>
             </a:r>
             <a:r>
-              <a:rPr sz="2900" b="1" i="0" spc="100">
+              <a:rPr sz="3329" b="1" i="0" spc="100">
                 <a:solidFill>
                   <a:srgbClr val="B8934E"/>
                 </a:solidFill>
@@ -7326,7 +7326,7 @@
               <a:t>ブランド</a:t>
             </a:r>
             <a:r>
-              <a:rPr sz="2900" b="1" i="0" spc="100">
+              <a:rPr sz="3329" b="1" i="0" spc="100">
                 <a:solidFill>
                   <a:srgbClr val="201C15"/>
                 </a:solidFill>
@@ -7410,7 +7410,7 @@
               </a:lnSpc>
             </a:pPr>
             <a:r>
-              <a:rPr sz="1200" b="1" i="0">
+              <a:rPr sz="1380" b="1" i="0">
                 <a:solidFill>
                   <a:srgbClr val="201C15"/>
                 </a:solidFill>
@@ -7450,7 +7450,7 @@
               </a:lnSpc>
             </a:pPr>
             <a:r>
-              <a:rPr sz="880" b="0" i="0">
+              <a:rPr sz="1010" b="0" i="0">
                 <a:solidFill>
                   <a:srgbClr val="201C15"/>
                 </a:solidFill>
@@ -7534,7 +7534,7 @@
               </a:lnSpc>
             </a:pPr>
             <a:r>
-              <a:rPr sz="1200" b="1" i="0">
+              <a:rPr sz="1380" b="1" i="0">
                 <a:solidFill>
                   <a:srgbClr val="201C15"/>
                 </a:solidFill>
@@ -7574,7 +7574,7 @@
               </a:lnSpc>
             </a:pPr>
             <a:r>
-              <a:rPr sz="880" b="0" i="0">
+              <a:rPr sz="1010" b="0" i="0">
                 <a:solidFill>
                   <a:srgbClr val="201C15"/>
                 </a:solidFill>
@@ -7658,7 +7658,7 @@
               </a:lnSpc>
             </a:pPr>
             <a:r>
-              <a:rPr sz="1200" b="1" i="0">
+              <a:rPr sz="1380" b="1" i="0">
                 <a:solidFill>
                   <a:srgbClr val="201C15"/>
                 </a:solidFill>
@@ -7698,7 +7698,7 @@
               </a:lnSpc>
             </a:pPr>
             <a:r>
-              <a:rPr sz="880" b="0" i="0">
+              <a:rPr sz="1010" b="0" i="0">
                 <a:solidFill>
                   <a:srgbClr val="201C15"/>
                 </a:solidFill>
@@ -7785,7 +7785,7 @@
               </a:spcAft>
             </a:pPr>
             <a:r>
-              <a:rPr sz="1500" b="0" i="1">
+              <a:rPr sz="1720" b="0" i="1">
                 <a:solidFill>
                   <a:srgbClr val="D8C08C"/>
                 </a:solidFill>
@@ -7805,7 +7805,7 @@
               </a:spcAft>
             </a:pPr>
             <a:r>
-              <a:rPr sz="1050" b="1" i="0">
+              <a:rPr sz="1210" b="1" i="0">
                 <a:solidFill>
                   <a:srgbClr val="FFFFFF"/>
                 </a:solidFill>
@@ -7825,7 +7825,7 @@
               </a:spcAft>
             </a:pPr>
             <a:r>
-              <a:rPr sz="1500" b="0" i="1">
+              <a:rPr sz="1720" b="0" i="1">
                 <a:solidFill>
                   <a:srgbClr val="D8C08C"/>
                 </a:solidFill>
@@ -7845,7 +7845,7 @@
               </a:spcAft>
             </a:pPr>
             <a:r>
-              <a:rPr sz="930" b="0" i="0">
+              <a:rPr sz="1070" b="0" i="0">
                 <a:solidFill>
                   <a:srgbClr val="ABA595"/>
                 </a:solidFill>
@@ -7862,7 +7862,7 @@
               </a:lnSpc>
             </a:pPr>
             <a:r>
-              <a:rPr sz="680" b="0" i="0">
+              <a:rPr sz="780" b="0" i="0">
                 <a:solidFill>
                   <a:srgbClr val="7E7868"/>
                 </a:solidFill>
@@ -7964,7 +7964,7 @@
               </a:lnSpc>
             </a:pPr>
             <a:r>
-              <a:rPr sz="1050" b="0" i="1" spc="250">
+              <a:rPr sz="1210" b="0" i="1" spc="250">
                 <a:solidFill>
                   <a:srgbClr val="8A6A32"/>
                 </a:solidFill>
@@ -8029,7 +8029,7 @@
         <p:spPr>
           <a:xfrm>
             <a:off x="738000" y="1008000"/>
-            <a:ext cx="10713600" cy="576000"/>
+            <a:ext cx="10713600" cy="666000"/>
           </a:xfrm>
           <a:prstGeom prst="rect">
             <a:avLst/>
@@ -8048,7 +8048,7 @@
               </a:lnSpc>
             </a:pPr>
             <a:r>
-              <a:rPr sz="2900" b="1" i="0" spc="100">
+              <a:rPr sz="3329" b="1" i="0" spc="100">
                 <a:solidFill>
                   <a:srgbClr val="201C15"/>
                 </a:solidFill>
@@ -8058,7 +8058,7 @@
               <a:t>よくいただく、</a:t>
             </a:r>
             <a:r>
-              <a:rPr sz="2900" b="1" i="0" spc="100">
+              <a:rPr sz="3329" b="1" i="0" spc="100">
                 <a:solidFill>
                   <a:srgbClr val="B8934E"/>
                 </a:solidFill>
@@ -8068,7 +8068,7 @@
               <a:t>4つ</a:t>
             </a:r>
             <a:r>
-              <a:rPr sz="2900" b="1" i="0" spc="100">
+              <a:rPr sz="3329" b="1" i="0" spc="100">
                 <a:solidFill>
                   <a:srgbClr val="201C15"/>
                 </a:solidFill>
@@ -8152,7 +8152,7 @@
               </a:lnSpc>
             </a:pPr>
             <a:r>
-              <a:rPr sz="1100" b="1" i="1">
+              <a:rPr sz="1260" b="1" i="1">
                 <a:solidFill>
                   <a:srgbClr val="8A6A32"/>
                 </a:solidFill>
@@ -8162,7 +8162,7 @@
               <a:t>Q. </a:t>
             </a:r>
             <a:r>
-              <a:rPr sz="1150" b="1" i="0">
+              <a:rPr sz="1320" b="1" i="0">
                 <a:solidFill>
                   <a:srgbClr val="201C15"/>
                 </a:solidFill>
@@ -8202,7 +8202,7 @@
               </a:lnSpc>
             </a:pPr>
             <a:r>
-              <a:rPr sz="880" b="0" i="0">
+              <a:rPr sz="1010" b="0" i="0">
                 <a:solidFill>
                   <a:srgbClr val="201C15"/>
                 </a:solidFill>
@@ -8212,7 +8212,7 @@
               <a:t>ローンチ前のため、実績数値はまだありません。だからこそ、料金は</a:t>
             </a:r>
             <a:r>
-              <a:rPr sz="880" b="1" i="0">
+              <a:rPr sz="1010" b="1" i="0">
                 <a:solidFill>
                   <a:srgbClr val="201C15"/>
                 </a:solidFill>
@@ -8222,7 +8222,7 @@
               <a:t>完全成果報酬</a:t>
             </a:r>
             <a:r>
-              <a:rPr sz="880" b="0" i="0">
+              <a:rPr sz="1010" b="0" i="0">
                 <a:solidFill>
                   <a:srgbClr val="201C15"/>
                 </a:solidFill>
@@ -8306,7 +8306,7 @@
               </a:lnSpc>
             </a:pPr>
             <a:r>
-              <a:rPr sz="1100" b="1" i="1">
+              <a:rPr sz="1260" b="1" i="1">
                 <a:solidFill>
                   <a:srgbClr val="8A6A32"/>
                 </a:solidFill>
@@ -8316,7 +8316,7 @@
               <a:t>Q. </a:t>
             </a:r>
             <a:r>
-              <a:rPr sz="1150" b="1" i="0">
+              <a:rPr sz="1320" b="1" i="0">
                 <a:solidFill>
                   <a:srgbClr val="201C15"/>
                 </a:solidFill>
@@ -8356,7 +8356,7 @@
               </a:lnSpc>
             </a:pPr>
             <a:r>
-              <a:rPr sz="880" b="0" i="0">
+              <a:rPr sz="1010" b="0" i="0">
                 <a:solidFill>
                   <a:srgbClr val="201C15"/>
                 </a:solidFill>
@@ -8366,7 +8366,7 @@
               <a:t>スカウト型媒体は成功報酬30%の例に加え、</a:t>
             </a:r>
             <a:r>
-              <a:rPr sz="880" b="1" i="0">
+              <a:rPr sz="1010" b="1" i="0">
                 <a:solidFill>
                   <a:srgbClr val="201C15"/>
                 </a:solidFill>
@@ -8376,7 +8376,7 @@
               <a:t>成約ゼロでも固定費・通数課金が発生</a:t>
             </a:r>
             <a:r>
-              <a:rPr sz="880" b="0" i="0">
+              <a:rPr sz="1010" b="0" i="0">
                 <a:solidFill>
                   <a:srgbClr val="201C15"/>
                 </a:solidFill>
@@ -8460,7 +8460,7 @@
               </a:lnSpc>
             </a:pPr>
             <a:r>
-              <a:rPr sz="1100" b="1" i="1">
+              <a:rPr sz="1260" b="1" i="1">
                 <a:solidFill>
                   <a:srgbClr val="8A6A32"/>
                 </a:solidFill>
@@ -8470,7 +8470,7 @@
               <a:t>Q. </a:t>
             </a:r>
             <a:r>
-              <a:rPr sz="1150" b="1" i="0">
+              <a:rPr sz="1320" b="1" i="0">
                 <a:solidFill>
                   <a:srgbClr val="201C15"/>
                 </a:solidFill>
@@ -8510,7 +8510,7 @@
               </a:lnSpc>
             </a:pPr>
             <a:r>
-              <a:rPr sz="880" b="1" i="0">
+              <a:rPr sz="1010" b="1" i="0">
                 <a:solidFill>
                   <a:srgbClr val="201C15"/>
                 </a:solidFill>
@@ -8520,7 +8520,7 @@
               <a:t>併用が前提の設計です。</a:t>
             </a:r>
             <a:r>
-              <a:rPr sz="880" b="0" i="0">
+              <a:rPr sz="1010" b="0" i="0">
                 <a:solidFill>
                   <a:srgbClr val="201C15"/>
                 </a:solidFill>
@@ -8604,7 +8604,7 @@
               </a:lnSpc>
             </a:pPr>
             <a:r>
-              <a:rPr sz="1100" b="1" i="1">
+              <a:rPr sz="1260" b="1" i="1">
                 <a:solidFill>
                   <a:srgbClr val="8A6A32"/>
                 </a:solidFill>
@@ -8614,7 +8614,7 @@
               <a:t>Q. </a:t>
             </a:r>
             <a:r>
-              <a:rPr sz="1150" b="1" i="0">
+              <a:rPr sz="1320" b="1" i="0">
                 <a:solidFill>
                   <a:srgbClr val="201C15"/>
                 </a:solidFill>
@@ -8654,7 +8654,7 @@
               </a:lnSpc>
             </a:pPr>
             <a:r>
-              <a:rPr sz="880" b="0" i="0">
+              <a:rPr sz="1010" b="0" i="0">
                 <a:solidFill>
                   <a:srgbClr val="201C15"/>
                 </a:solidFill>
@@ -8664,7 +8664,7 @@
               <a:t>エントリーは法人単位の簡単な書類から。</a:t>
             </a:r>
             <a:r>
-              <a:rPr sz="880" b="1" i="0">
+              <a:rPr sz="1010" b="1" i="0">
                 <a:solidFill>
                   <a:srgbClr val="201C15"/>
                 </a:solidFill>
@@ -8674,7 +8674,7 @@
               <a:t>プロフィール制作は当社が伴走</a:t>
             </a:r>
             <a:r>
-              <a:rPr sz="880" b="0" i="0">
+              <a:rPr sz="1010" b="0" i="0">
                 <a:solidFill>
                   <a:srgbClr val="201C15"/>
                 </a:solidFill>
@@ -8758,7 +8758,7 @@
               </a:lnSpc>
             </a:pPr>
             <a:r>
-              <a:rPr sz="1050" b="0" i="0">
+              <a:rPr sz="1210" b="0" i="0">
                 <a:solidFill>
                   <a:srgbClr val="FFFFFF"/>
                 </a:solidFill>
@@ -8768,7 +8768,7 @@
               <a:t>4つに共通する設計 — </a:t>
             </a:r>
             <a:r>
-              <a:rPr sz="1050" b="1" i="0">
+              <a:rPr sz="1210" b="1" i="0">
                 <a:solidFill>
                   <a:srgbClr val="D8C08C"/>
                 </a:solidFill>
@@ -8778,7 +8778,7 @@
               <a:t>貴社がリスクを取らずに、試せること。</a:t>
             </a:r>
             <a:r>
-              <a:rPr sz="1050" b="0" i="0">
+              <a:rPr sz="1210" b="0" i="0">
                 <a:solidFill>
                   <a:srgbClr val="FFFFFF"/>
                 </a:solidFill>
@@ -8880,7 +8880,7 @@
               </a:lnSpc>
             </a:pPr>
             <a:r>
-              <a:rPr sz="1050" b="0" i="1" spc="250">
+              <a:rPr sz="1210" b="0" i="1" spc="250">
                 <a:solidFill>
                   <a:srgbClr val="8A6A32"/>
                 </a:solidFill>
@@ -8945,7 +8945,7 @@
         <p:spPr>
           <a:xfrm>
             <a:off x="738000" y="1008000"/>
-            <a:ext cx="10713600" cy="576000"/>
+            <a:ext cx="10713600" cy="666000"/>
           </a:xfrm>
           <a:prstGeom prst="rect">
             <a:avLst/>
@@ -8964,7 +8964,7 @@
               </a:lnSpc>
             </a:pPr>
             <a:r>
-              <a:rPr sz="2900" b="1" i="0" spc="100">
+              <a:rPr sz="3329" b="1" i="0" spc="100">
                 <a:solidFill>
                   <a:srgbClr val="201C15"/>
                 </a:solidFill>
@@ -8974,7 +8974,7 @@
               <a:t>成約まで、</a:t>
             </a:r>
             <a:r>
-              <a:rPr sz="2900" b="1" i="0" spc="100">
+              <a:rPr sz="3329" b="1" i="0" spc="100">
                 <a:solidFill>
                   <a:srgbClr val="B8934E"/>
                 </a:solidFill>
@@ -8984,7 +8984,7 @@
               <a:t>費用はかかりません</a:t>
             </a:r>
             <a:r>
-              <a:rPr sz="2900" b="1" i="0" spc="100">
+              <a:rPr sz="3329" b="1" i="0" spc="100">
                 <a:solidFill>
                   <a:srgbClr val="201C15"/>
                 </a:solidFill>
@@ -9071,7 +9071,7 @@
               </a:spcAft>
             </a:pPr>
             <a:r>
-              <a:rPr sz="850" b="0" i="0" spc="250">
+              <a:rPr sz="980" b="0" i="0" spc="250">
                 <a:solidFill>
                   <a:srgbClr val="D8C08C"/>
                 </a:solidFill>
@@ -9091,7 +9091,7 @@
               </a:spcAft>
             </a:pPr>
             <a:r>
-              <a:rPr sz="4600" b="0" i="0">
+              <a:rPr sz="5290" b="0" i="0">
                 <a:solidFill>
                   <a:srgbClr val="FFFFFF"/>
                 </a:solidFill>
@@ -9101,7 +9101,7 @@
               <a:t>20</a:t>
             </a:r>
             <a:r>
-              <a:rPr sz="1800" b="1" i="0">
+              <a:rPr sz="2070" b="1" i="0">
                 <a:solidFill>
                   <a:srgbClr val="D8C08C"/>
                 </a:solidFill>
@@ -9121,7 +9121,7 @@
               </a:spcAft>
             </a:pPr>
             <a:r>
-              <a:rPr sz="850" b="0" i="0">
+              <a:rPr sz="980" b="0" i="0">
                 <a:solidFill>
                   <a:srgbClr val="ABA595"/>
                 </a:solidFill>
@@ -9141,7 +9141,7 @@
               </a:spcBef>
             </a:pPr>
             <a:r>
-              <a:rPr sz="1200" b="1" i="0">
+              <a:rPr sz="1380" b="1" i="0">
                 <a:solidFill>
                   <a:srgbClr val="FFFFFF"/>
                 </a:solidFill>
@@ -9151,7 +9151,7 @@
               <a:t>貴社の取り分 </a:t>
             </a:r>
             <a:r>
-              <a:rPr sz="1200" b="1" i="0">
+              <a:rPr sz="1380" b="1" i="0">
                 <a:solidFill>
                   <a:srgbClr val="D8C08C"/>
                 </a:solidFill>
@@ -9326,7 +9326,7 @@
               </a:spcAft>
             </a:pPr>
             <a:r>
-              <a:rPr sz="800" b="0" i="0" spc="250">
+              <a:rPr sz="919" b="0" i="0" spc="250">
                 <a:solidFill>
                   <a:srgbClr val="8F8A7B"/>
                 </a:solidFill>
@@ -9346,7 +9346,7 @@
               </a:spcAft>
             </a:pPr>
             <a:r>
-              <a:rPr sz="2400" b="0" i="0">
+              <a:rPr sz="2760" b="0" i="0">
                 <a:solidFill>
                   <a:srgbClr val="201C15"/>
                 </a:solidFill>
@@ -9356,7 +9356,7 @@
               <a:t>¥0</a:t>
             </a:r>
             <a:r>
-              <a:rPr sz="1050" b="1" i="0">
+              <a:rPr sz="1210" b="1" i="0">
                 <a:solidFill>
                   <a:srgbClr val="201C15"/>
                 </a:solidFill>
@@ -9373,14 +9373,14 @@
               </a:lnSpc>
             </a:pPr>
             <a:r>
-              <a:rPr sz="850" b="0" i="0">
+              <a:rPr sz="980" b="0" i="0">
                 <a:solidFill>
                   <a:srgbClr val="8F8A7B"/>
                 </a:solidFill>
                 <a:latin typeface="Yu Gothic"/>
                 <a:ea typeface="游ゴシック"/>
               </a:rPr>
-              <a:t>登録・掲載・スカウト・指名の受信・面談まで、すべて無料。</a:t>
+              <a:t>登録・掲載・指名の受信・面談まで、すべて無料。</a:t>
             </a:r>
           </a:p>
         </p:txBody>
@@ -9504,7 +9504,7 @@
               </a:spcAft>
             </a:pPr>
             <a:r>
-              <a:rPr sz="800" b="0" i="0" spc="250">
+              <a:rPr sz="919" b="0" i="0" spc="250">
                 <a:solidFill>
                   <a:srgbClr val="8A6A32"/>
                 </a:solidFill>
@@ -9524,7 +9524,7 @@
               </a:spcAft>
             </a:pPr>
             <a:r>
-              <a:rPr sz="2200" b="0" i="0">
+              <a:rPr sz="2530" b="0" i="0">
                 <a:solidFill>
                   <a:srgbClr val="201C15"/>
                 </a:solidFill>
@@ -9534,7 +9534,7 @@
               <a:t>¥50,000</a:t>
             </a:r>
             <a:r>
-              <a:rPr sz="1050" b="1" i="0">
+              <a:rPr sz="1210" b="1" i="0">
                 <a:solidFill>
                   <a:srgbClr val="201C15"/>
                 </a:solidFill>
@@ -9551,7 +9551,7 @@
               </a:lnSpc>
             </a:pPr>
             <a:r>
-              <a:rPr sz="850" b="0" i="0">
+              <a:rPr sz="980" b="0" i="0">
                 <a:solidFill>
                   <a:srgbClr val="8F8A7B"/>
                 </a:solidFill>
@@ -9591,14 +9591,14 @@
               </a:lnSpc>
             </a:pPr>
             <a:r>
-              <a:rPr sz="700" b="0" i="0">
+              <a:rPr sz="800" b="0" i="0">
                 <a:solidFill>
                   <a:srgbClr val="8F8A7B"/>
                 </a:solidFill>
                 <a:latin typeface="Yu Gothic"/>
                 <a:ea typeface="游ゴシック"/>
               </a:rPr>
-              <a:t>スカウト通数課金・広告費・送客費・掲載料は一切なし。　※平均決定単価の出典: 厚生労働省「令和6年度職業紹介事業報告書の集計結果」</a:t>
+              <a:t>通数課金・広告費・送客費・掲載料は一切なし。　※平均決定単価の出典: 厚生労働省「令和6年度職業紹介事業報告書の集計結果」</a:t>
             </a:r>
           </a:p>
         </p:txBody>
@@ -9693,7 +9693,7 @@
               </a:lnSpc>
             </a:pPr>
             <a:r>
-              <a:rPr sz="1050" b="0" i="1" spc="250">
+              <a:rPr sz="1210" b="0" i="1" spc="250">
                 <a:solidFill>
                   <a:srgbClr val="8A6A32"/>
                 </a:solidFill>
@@ -9758,7 +9758,7 @@
         <p:spPr>
           <a:xfrm>
             <a:off x="738000" y="1008000"/>
-            <a:ext cx="10713600" cy="576000"/>
+            <a:ext cx="10713600" cy="666000"/>
           </a:xfrm>
           <a:prstGeom prst="rect">
             <a:avLst/>
@@ -9777,7 +9777,7 @@
               </a:lnSpc>
             </a:pPr>
             <a:r>
-              <a:rPr sz="2900" b="1" i="0" spc="100">
+              <a:rPr sz="3329" b="1" i="0" spc="100">
                 <a:solidFill>
                   <a:srgbClr val="201C15"/>
                 </a:solidFill>
@@ -9787,7 +9787,7 @@
               <a:t>ローンチパートナーを、</a:t>
             </a:r>
             <a:r>
-              <a:rPr sz="2900" b="1" i="0" spc="100">
+              <a:rPr sz="3329" b="1" i="0" spc="100">
                 <a:solidFill>
                   <a:srgbClr val="B8934E"/>
                 </a:solidFill>
@@ -9797,7 +9797,7 @@
               <a:t>募集します</a:t>
             </a:r>
             <a:r>
-              <a:rPr sz="2900" b="1" i="0" spc="100">
+              <a:rPr sz="3329" b="1" i="0" spc="100">
                 <a:solidFill>
                   <a:srgbClr val="201C15"/>
                 </a:solidFill>
@@ -9925,7 +9925,7 @@
               </a:lnSpc>
             </a:pPr>
             <a:r>
-              <a:rPr sz="1250" b="1" i="0">
+              <a:rPr sz="1440" b="1" i="0">
                 <a:solidFill>
                   <a:srgbClr val="201C15"/>
                 </a:solidFill>
@@ -9965,7 +9965,7 @@
               </a:lnSpc>
             </a:pPr>
             <a:r>
-              <a:rPr sz="880" b="0" i="0">
+              <a:rPr sz="1010" b="0" i="0">
                 <a:solidFill>
                   <a:srgbClr val="8F8A7B"/>
                 </a:solidFill>
@@ -10093,7 +10093,7 @@
               </a:lnSpc>
             </a:pPr>
             <a:r>
-              <a:rPr sz="1250" b="1" i="0">
+              <a:rPr sz="1440" b="1" i="0">
                 <a:solidFill>
                   <a:srgbClr val="201C15"/>
                 </a:solidFill>
@@ -10133,7 +10133,7 @@
               </a:lnSpc>
             </a:pPr>
             <a:r>
-              <a:rPr sz="880" b="0" i="0">
+              <a:rPr sz="1010" b="0" i="0">
                 <a:solidFill>
                   <a:srgbClr val="8F8A7B"/>
                 </a:solidFill>
@@ -10217,7 +10217,7 @@
               </a:lnSpc>
             </a:pPr>
             <a:r>
-              <a:rPr sz="1250" b="1" i="0">
+              <a:rPr sz="1440" b="1" i="0">
                 <a:solidFill>
                   <a:srgbClr val="201C15"/>
                 </a:solidFill>
@@ -10257,7 +10257,7 @@
               </a:lnSpc>
             </a:pPr>
             <a:r>
-              <a:rPr sz="880" b="0" i="0">
+              <a:rPr sz="1010" b="0" i="0">
                 <a:solidFill>
                   <a:srgbClr val="8F8A7B"/>
                 </a:solidFill>
@@ -10344,7 +10344,7 @@
               </a:spcAft>
             </a:pPr>
             <a:r>
-              <a:rPr sz="1150" b="1" i="0">
+              <a:rPr sz="1320" b="1" i="0">
                 <a:solidFill>
                   <a:srgbClr val="FFFFFF"/>
                 </a:solidFill>
@@ -10364,7 +10364,7 @@
               </a:spcAft>
             </a:pPr>
             <a:r>
-              <a:rPr sz="1050" b="0" i="1">
+              <a:rPr sz="1210" b="0" i="1">
                 <a:solidFill>
                   <a:srgbClr val="D8C08C"/>
                 </a:solidFill>
@@ -10374,14 +10374,14 @@
               <a:t>01　</a:t>
             </a:r>
             <a:r>
-              <a:rPr sz="1050" b="1" i="0">
+              <a:rPr sz="1210" b="1" i="0">
                 <a:solidFill>
                   <a:srgbClr val="FFFFFF"/>
                 </a:solidFill>
                 <a:latin typeface="Yu Gothic"/>
                 <a:ea typeface="游ゴシック"/>
               </a:rPr>
-              <a:t>初期ほど、スカウトが効く</a:t>
+              <a:t>初期ほど、指名が集中する</a:t>
             </a:r>
           </a:p>
           <a:p>
@@ -10394,14 +10394,14 @@
               </a:spcAft>
             </a:pPr>
             <a:r>
-              <a:rPr sz="830" b="0" i="0">
+              <a:rPr sz="950" b="0" i="0">
                 <a:solidFill>
                   <a:srgbClr val="ABA595"/>
                 </a:solidFill>
                 <a:latin typeface="Yu Gothic"/>
                 <a:ea typeface="游ゴシック"/>
               </a:rPr>
-              <a:t>参加CAを限定してローンチ。送信競争が最も少ない時期に始められる。</a:t>
+              <a:t>参加CAを限定してローンチ。掲載が少ない時期ほど、1人あたりの露出が大きい。</a:t>
             </a:r>
           </a:p>
           <a:p>
@@ -10414,7 +10414,7 @@
               </a:spcAft>
             </a:pPr>
             <a:r>
-              <a:rPr sz="1050" b="0" i="1">
+              <a:rPr sz="1210" b="0" i="1">
                 <a:solidFill>
                   <a:srgbClr val="D8C08C"/>
                 </a:solidFill>
@@ -10424,7 +10424,7 @@
               <a:t>02　</a:t>
             </a:r>
             <a:r>
-              <a:rPr sz="1050" b="1" i="0">
+              <a:rPr sz="1210" b="1" i="0">
                 <a:solidFill>
                   <a:srgbClr val="FFFFFF"/>
                 </a:solidFill>
@@ -10444,7 +10444,7 @@
               </a:spcAft>
             </a:pPr>
             <a:r>
-              <a:rPr sz="830" b="0" i="0">
+              <a:rPr sz="950" b="0" i="0">
                 <a:solidFill>
                   <a:srgbClr val="ABA595"/>
                 </a:solidFill>
@@ -10464,7 +10464,7 @@
               </a:spcAft>
             </a:pPr>
             <a:r>
-              <a:rPr sz="1050" b="0" i="1">
+              <a:rPr sz="1210" b="0" i="1">
                 <a:solidFill>
                   <a:srgbClr val="D8C08C"/>
                 </a:solidFill>
@@ -10474,7 +10474,7 @@
               <a:t>03　</a:t>
             </a:r>
             <a:r>
-              <a:rPr sz="1050" b="1" i="0">
+              <a:rPr sz="1210" b="1" i="0">
                 <a:solidFill>
                   <a:srgbClr val="FFFFFF"/>
                 </a:solidFill>
@@ -10494,7 +10494,7 @@
               </a:spcAft>
             </a:pPr>
             <a:r>
-              <a:rPr sz="830" b="0" i="0">
+              <a:rPr sz="950" b="0" i="0">
                 <a:solidFill>
                   <a:srgbClr val="ABA595"/>
                 </a:solidFill>
@@ -10534,7 +10534,7 @@
               </a:lnSpc>
             </a:pPr>
             <a:r>
-              <a:rPr sz="700" b="0" i="0">
+              <a:rPr sz="800" b="0" i="0">
                 <a:solidFill>
                   <a:srgbClr val="8F8A7B"/>
                 </a:solidFill>
@@ -10680,7 +10680,7 @@
               </a:lnSpc>
             </a:pPr>
             <a:r>
-              <a:rPr sz="1050" b="0" i="1" spc="250">
+              <a:rPr sz="1210" b="0" i="1" spc="250">
                 <a:solidFill>
                   <a:srgbClr val="D8C08C"/>
                 </a:solidFill>
@@ -10764,7 +10764,7 @@
               </a:lnSpc>
             </a:pPr>
             <a:r>
-              <a:rPr sz="2700" b="1" i="0" spc="100">
+              <a:rPr sz="3100" b="1" i="0" spc="100">
                 <a:solidFill>
                   <a:srgbClr val="FFFFFF"/>
                 </a:solidFill>
@@ -10781,24 +10781,24 @@
               </a:lnSpc>
             </a:pPr>
             <a:r>
-              <a:rPr sz="2700" b="1" i="0" spc="100">
+              <a:rPr sz="3100" b="1" i="0" spc="100">
                 <a:solidFill>
                   <a:srgbClr val="D8C08C"/>
                 </a:solidFill>
                 <a:latin typeface="Garamond"/>
                 <a:ea typeface="游明朝"/>
               </a:rPr>
-              <a:t>スカウトも指名も</a:t>
-            </a:r>
-            <a:r>
-              <a:rPr sz="2700" b="1" i="0" spc="100">
+              <a:t>“指名”</a:t>
+            </a:r>
+            <a:r>
+              <a:rPr sz="3100" b="1" i="0" spc="100">
                 <a:solidFill>
                   <a:srgbClr val="FFFFFF"/>
                 </a:solidFill>
                 <a:latin typeface="Garamond"/>
                 <a:ea typeface="游明朝"/>
               </a:rPr>
-              <a:t>、届く。</a:t>
+              <a:t>は届く。</a:t>
             </a:r>
           </a:p>
         </p:txBody>
@@ -10831,7 +10831,7 @@
               </a:lnSpc>
             </a:pPr>
             <a:r>
-              <a:rPr sz="1050" b="0" i="0" spc="100">
+              <a:rPr sz="1210" b="0" i="0" spc="100">
                 <a:solidFill>
                   <a:srgbClr val="ABA595"/>
                 </a:solidFill>
@@ -10915,7 +10915,7 @@
               </a:lnSpc>
             </a:pPr>
             <a:r>
-              <a:rPr sz="930" b="0" i="0">
+              <a:rPr sz="1070" b="0" i="0">
                 <a:solidFill>
                   <a:srgbClr val="D8C08C"/>
                 </a:solidFill>
@@ -11002,7 +11002,7 @@
               </a:spcAft>
             </a:pPr>
             <a:r>
-              <a:rPr sz="2200" b="0" i="0">
+              <a:rPr sz="2530" b="0" i="0">
                 <a:solidFill>
                   <a:srgbClr val="FFFFFF"/>
                 </a:solidFill>
@@ -11012,7 +11012,7 @@
               <a:t>MarkGate</a:t>
             </a:r>
             <a:r>
-              <a:rPr sz="2200" b="0" i="0">
+              <a:rPr sz="2530" b="0" i="0">
                 <a:solidFill>
                   <a:srgbClr val="B8934E"/>
                 </a:solidFill>
@@ -11029,7 +11029,7 @@
               </a:lnSpc>
             </a:pPr>
             <a:r>
-              <a:rPr sz="700" b="0" i="0" spc="300">
+              <a:rPr sz="800" b="0" i="0" spc="300">
                 <a:solidFill>
                   <a:srgbClr val="7E7868"/>
                 </a:solidFill>
@@ -11069,7 +11069,7 @@
               </a:lnSpc>
             </a:pPr>
             <a:r>
-              <a:rPr sz="880" b="0" i="0">
+              <a:rPr sz="1010" b="0" i="0">
                 <a:solidFill>
                   <a:srgbClr val="ABA595"/>
                 </a:solidFill>
@@ -11086,7 +11086,7 @@
               </a:lnSpc>
             </a:pPr>
             <a:r>
-              <a:rPr sz="880" b="0" i="0">
+              <a:rPr sz="1010" b="0" i="0">
                 <a:solidFill>
                   <a:srgbClr val="ABA595"/>
                 </a:solidFill>
@@ -11103,7 +11103,7 @@
               </a:lnSpc>
             </a:pPr>
             <a:r>
-              <a:rPr sz="880" b="0" i="0">
+              <a:rPr sz="1010" b="0" i="0">
                 <a:solidFill>
                   <a:srgbClr val="ABA595"/>
                 </a:solidFill>
@@ -11143,7 +11143,7 @@
               </a:lnSpc>
             </a:pPr>
             <a:r>
-              <a:rPr sz="680" b="0" i="0">
+              <a:rPr sz="780" b="0" i="0">
                 <a:solidFill>
                   <a:srgbClr val="7E7868"/>
                 </a:solidFill>
@@ -11183,7 +11183,7 @@
               </a:lnSpc>
             </a:pPr>
             <a:r>
-              <a:rPr sz="950" b="0" i="1">
+              <a:rPr sz="1090" b="0" i="1">
                 <a:solidFill>
                   <a:srgbClr val="D8C08C"/>
                 </a:solidFill>
@@ -11285,7 +11285,7 @@
               </a:lnSpc>
             </a:pPr>
             <a:r>
-              <a:rPr sz="1050" b="0" i="1" spc="250">
+              <a:rPr sz="1210" b="0" i="1" spc="250">
                 <a:solidFill>
                   <a:srgbClr val="8A6A32"/>
                 </a:solidFill>
@@ -11350,7 +11350,7 @@
         <p:spPr>
           <a:xfrm>
             <a:off x="738000" y="1008000"/>
-            <a:ext cx="10713600" cy="576000"/>
+            <a:ext cx="10713600" cy="666000"/>
           </a:xfrm>
           <a:prstGeom prst="rect">
             <a:avLst/>
@@ -11369,17 +11369,17 @@
               </a:lnSpc>
             </a:pPr>
             <a:r>
-              <a:rPr sz="2900" b="1" i="0" spc="100">
+              <a:rPr sz="3329" b="1" i="0" spc="100">
                 <a:solidFill>
                   <a:srgbClr val="201C15"/>
                 </a:solidFill>
                 <a:latin typeface="Garamond"/>
                 <a:ea typeface="游明朝"/>
               </a:rPr>
-              <a:t>絞るから、</a:t>
-            </a:r>
-            <a:r>
-              <a:rPr sz="2900" b="1" i="0" spc="100">
+              <a:t>選ばれるから、</a:t>
+            </a:r>
+            <a:r>
+              <a:rPr sz="3329" b="1" i="0" spc="100">
                 <a:solidFill>
                   <a:srgbClr val="B8934E"/>
                 </a:solidFill>
@@ -11389,7 +11389,7 @@
               <a:t>届く</a:t>
             </a:r>
             <a:r>
-              <a:rPr sz="2900" b="1" i="0" spc="100">
+              <a:rPr sz="3329" b="1" i="0" spc="100">
                 <a:solidFill>
                   <a:srgbClr val="201C15"/>
                 </a:solidFill>
@@ -11409,7 +11409,7 @@
         </p:nvSpPr>
         <p:spPr>
           <a:xfrm>
-            <a:off x="738000" y="1602000"/>
+            <a:off x="738000" y="1692000"/>
             <a:ext cx="10713600" cy="324000"/>
           </a:xfrm>
           <a:prstGeom prst="rect">
@@ -11429,14 +11429,14 @@
               </a:lnSpc>
             </a:pPr>
             <a:r>
-              <a:rPr sz="1050" b="0" i="0" spc="100">
+              <a:rPr sz="1210" b="0" i="0" spc="100">
                 <a:solidFill>
                   <a:srgbClr val="8F8A7B"/>
                 </a:solidFill>
                 <a:latin typeface="Yu Gothic"/>
                 <a:ea typeface="游ゴシック"/>
               </a:rPr>
-              <a:t>トップクラスのCAだけが参加できる、スカウトと指名の双方向マッチングです。</a:t>
+              <a:t>トップクラスのCAだけが参加できる、“指名”型のマッチングです。</a:t>
             </a:r>
           </a:p>
         </p:txBody>
@@ -11560,7 +11560,7 @@
               </a:spcAft>
             </a:pPr>
             <a:r>
-              <a:rPr sz="1600" b="0" i="1">
+              <a:rPr sz="1839" b="0" i="1">
                 <a:solidFill>
                   <a:srgbClr val="8A6A32"/>
                 </a:solidFill>
@@ -11580,14 +11580,14 @@
               </a:spcAft>
             </a:pPr>
             <a:r>
-              <a:rPr sz="1350" b="1" i="0">
+              <a:rPr sz="1550" b="1" i="0">
                 <a:solidFill>
                   <a:srgbClr val="201C15"/>
                 </a:solidFill>
                 <a:latin typeface="Yu Gothic"/>
                 <a:ea typeface="游ゴシック"/>
               </a:rPr>
-              <a:t>届くスカウト</a:t>
+              <a:t>トップCA限定</a:t>
             </a:r>
           </a:p>
           <a:p>
@@ -11600,14 +11600,14 @@
               </a:spcAft>
             </a:pPr>
             <a:r>
-              <a:rPr sz="680" b="0" i="0" spc="200">
+              <a:rPr sz="780" b="0" i="0" spc="200">
                 <a:solidFill>
                   <a:srgbClr val="8F8A7B"/>
                 </a:solidFill>
                 <a:latin typeface="Yu Gothic"/>
                 <a:ea typeface="游ゴシック"/>
               </a:rPr>
-              <a:t>SCOUTS THAT LAND</a:t>
+              <a:t>VETTED ADVISORS</a:t>
             </a:r>
           </a:p>
           <a:p>
@@ -11617,14 +11617,14 @@
               </a:lnSpc>
             </a:pPr>
             <a:r>
-              <a:rPr sz="950" b="0" i="0">
+              <a:rPr sz="1090" b="0" i="0">
                 <a:solidFill>
                   <a:srgbClr val="201C15"/>
                 </a:solidFill>
                 <a:latin typeface="Yu Gothic"/>
                 <a:ea typeface="游ゴシック"/>
               </a:rPr>
-              <a:t>送り手をトップクラスのCAに限定。総量が絞られ、1通が読まれる。</a:t>
+              <a:t>実績・専門性・支援品質の審査制。掲載されていること自体が証明になる。</a:t>
             </a:r>
           </a:p>
         </p:txBody>
@@ -11704,7 +11704,7 @@
               </a:spcAft>
             </a:pPr>
             <a:r>
-              <a:rPr sz="1600" b="0" i="1">
+              <a:rPr sz="1839" b="0" i="1">
                 <a:solidFill>
                   <a:srgbClr val="D8C08C"/>
                 </a:solidFill>
@@ -11724,14 +11724,14 @@
               </a:spcAft>
             </a:pPr>
             <a:r>
-              <a:rPr sz="1350" b="1" i="0">
+              <a:rPr sz="1550" b="1" i="0">
                 <a:solidFill>
                   <a:srgbClr val="FFFFFF"/>
                 </a:solidFill>
                 <a:latin typeface="Yu Gothic"/>
                 <a:ea typeface="游ゴシック"/>
               </a:rPr>
-              <a:t>指名も届く</a:t>
+              <a:t>指名が届く</a:t>
             </a:r>
           </a:p>
           <a:p>
@@ -11744,7 +11744,7 @@
               </a:spcAft>
             </a:pPr>
             <a:r>
-              <a:rPr sz="680" b="0" i="0" spc="200">
+              <a:rPr sz="780" b="0" i="0" spc="200">
                 <a:solidFill>
                   <a:srgbClr val="7E7868"/>
                 </a:solidFill>
@@ -11761,14 +11761,14 @@
               </a:lnSpc>
             </a:pPr>
             <a:r>
-              <a:rPr sz="950" b="0" i="0">
+              <a:rPr sz="1090" b="0" i="0">
                 <a:solidFill>
                   <a:srgbClr val="ABA595"/>
                 </a:solidFill>
                 <a:latin typeface="Yu Gothic"/>
                 <a:ea typeface="游ゴシック"/>
               </a:rPr>
-              <a:t>求職者がプロフィールを見て指名。受け身でも温度の高い面談が届く。</a:t>
+              <a:t>求職者がプロフィールを見て指名。温度の高い面談が、送信ゼロで届く。</a:t>
             </a:r>
           </a:p>
         </p:txBody>
@@ -11892,7 +11892,7 @@
               </a:spcAft>
             </a:pPr>
             <a:r>
-              <a:rPr sz="1600" b="0" i="1">
+              <a:rPr sz="1839" b="0" i="1">
                 <a:solidFill>
                   <a:srgbClr val="8A6A32"/>
                 </a:solidFill>
@@ -11912,7 +11912,7 @@
               </a:spcAft>
             </a:pPr>
             <a:r>
-              <a:rPr sz="1350" b="1" i="0">
+              <a:rPr sz="1550" b="1" i="0">
                 <a:solidFill>
                   <a:srgbClr val="201C15"/>
                 </a:solidFill>
@@ -11932,7 +11932,7 @@
               </a:spcAft>
             </a:pPr>
             <a:r>
-              <a:rPr sz="680" b="0" i="0" spc="200">
+              <a:rPr sz="780" b="0" i="0" spc="200">
                 <a:solidFill>
                   <a:srgbClr val="8F8A7B"/>
                 </a:solidFill>
@@ -11949,7 +11949,7 @@
               </a:lnSpc>
             </a:pPr>
             <a:r>
-              <a:rPr sz="950" b="0" i="0">
+              <a:rPr sz="1090" b="0" i="0">
                 <a:solidFill>
                   <a:srgbClr val="201C15"/>
                 </a:solidFill>
@@ -12051,7 +12051,7 @@
               </a:lnSpc>
             </a:pPr>
             <a:r>
-              <a:rPr sz="1050" b="0" i="1" spc="250">
+              <a:rPr sz="1210" b="0" i="1" spc="250">
                 <a:solidFill>
                   <a:srgbClr val="8A6A32"/>
                 </a:solidFill>
@@ -12116,7 +12116,7 @@
         <p:spPr>
           <a:xfrm>
             <a:off x="738000" y="1008000"/>
-            <a:ext cx="10713600" cy="576000"/>
+            <a:ext cx="10713600" cy="666000"/>
           </a:xfrm>
           <a:prstGeom prst="rect">
             <a:avLst/>
@@ -12135,7 +12135,7 @@
               </a:lnSpc>
             </a:pPr>
             <a:r>
-              <a:rPr sz="2900" b="1" i="0" spc="100">
+              <a:rPr sz="3329" b="1" i="0" spc="100">
                 <a:solidFill>
                   <a:srgbClr val="201C15"/>
                 </a:solidFill>
@@ -12145,7 +12145,7 @@
               <a:t>スカウトは、もう</a:t>
             </a:r>
             <a:r>
-              <a:rPr sz="2900" b="1" i="0" spc="100">
+              <a:rPr sz="3329" b="1" i="0" spc="100">
                 <a:solidFill>
                   <a:srgbClr val="A03A2A"/>
                 </a:solidFill>
@@ -12155,7 +12155,7 @@
               <a:t>読まれていない</a:t>
             </a:r>
             <a:r>
-              <a:rPr sz="2900" b="1" i="0" spc="100">
+              <a:rPr sz="3329" b="1" i="0" spc="100">
                 <a:solidFill>
                   <a:srgbClr val="201C15"/>
                 </a:solidFill>
@@ -12175,7 +12175,7 @@
         </p:nvSpPr>
         <p:spPr>
           <a:xfrm>
-            <a:off x="738000" y="1602000"/>
+            <a:off x="738000" y="1692000"/>
             <a:ext cx="10713600" cy="324000"/>
           </a:xfrm>
           <a:prstGeom prst="rect">
@@ -12195,7 +12195,7 @@
               </a:lnSpc>
             </a:pPr>
             <a:r>
-              <a:rPr sz="1050" b="0" i="0" spc="100">
+              <a:rPr sz="1210" b="0" i="0" spc="100">
                 <a:solidFill>
                   <a:srgbClr val="8F8A7B"/>
                 </a:solidFill>
@@ -12326,7 +12326,7 @@
               </a:spcAft>
             </a:pPr>
             <a:r>
-              <a:rPr sz="850" b="0" i="1" spc="200">
+              <a:rPr sz="980" b="0" i="1" spc="200">
                 <a:solidFill>
                   <a:srgbClr val="8A6A32"/>
                 </a:solidFill>
@@ -12346,7 +12346,7 @@
               </a:spcAft>
             </a:pPr>
             <a:r>
-              <a:rPr sz="3800" b="0" i="0">
+              <a:rPr sz="4370" b="0" i="0">
                 <a:solidFill>
                   <a:srgbClr val="201C15"/>
                 </a:solidFill>
@@ -12356,7 +12356,7 @@
               <a:t>41,800</a:t>
             </a:r>
             <a:r>
-              <a:rPr sz="1300" b="1" i="0">
+              <a:rPr sz="1490" b="1" i="0">
                 <a:solidFill>
                   <a:srgbClr val="201C15"/>
                 </a:solidFill>
@@ -12376,7 +12376,7 @@
               </a:spcAft>
             </a:pPr>
             <a:r>
-              <a:rPr sz="730" b="0" i="0">
+              <a:rPr sz="840" b="0" i="0">
                 <a:solidFill>
                   <a:srgbClr val="8F8A7B"/>
                 </a:solidFill>
@@ -12399,7 +12399,7 @@
               </a:spcAft>
             </a:pPr>
             <a:r>
-              <a:rPr sz="2300" b="0" i="0">
+              <a:rPr sz="2640" b="0" i="0">
                 <a:solidFill>
                   <a:srgbClr val="201C15"/>
                 </a:solidFill>
@@ -12409,7 +12409,7 @@
               <a:t>9,700</a:t>
             </a:r>
             <a:r>
-              <a:rPr sz="1100" b="1" i="0">
+              <a:rPr sz="1260" b="1" i="0">
                 <a:solidFill>
                   <a:srgbClr val="201C15"/>
                 </a:solidFill>
@@ -12426,7 +12426,7 @@
               </a:lnSpc>
             </a:pPr>
             <a:r>
-              <a:rPr sz="730" b="0" i="0">
+              <a:rPr sz="840" b="0" i="0">
                 <a:solidFill>
                   <a:srgbClr val="8F8A7B"/>
                 </a:solidFill>
@@ -12510,7 +12510,7 @@
               </a:lnSpc>
             </a:pPr>
             <a:r>
-              <a:rPr sz="1500" b="0" i="0">
+              <a:rPr sz="1720" b="0" i="0">
                 <a:solidFill>
                   <a:srgbClr val="8F8A7B"/>
                 </a:solidFill>
@@ -12597,7 +12597,7 @@
               </a:spcAft>
             </a:pPr>
             <a:r>
-              <a:rPr sz="850" b="0" i="1" spc="200">
+              <a:rPr sz="980" b="0" i="1" spc="200">
                 <a:solidFill>
                   <a:srgbClr val="D8C08C"/>
                 </a:solidFill>
@@ -12617,7 +12617,7 @@
               </a:spcAft>
             </a:pPr>
             <a:r>
-              <a:rPr sz="3800" b="0" i="0">
+              <a:rPr sz="4370" b="0" i="0">
                 <a:solidFill>
                   <a:srgbClr val="FFFFFF"/>
                 </a:solidFill>
@@ -12627,7 +12627,7 @@
               <a:t>2−10</a:t>
             </a:r>
             <a:r>
-              <a:rPr sz="1400" b="1" i="0">
+              <a:rPr sz="1610" b="1" i="0">
                 <a:solidFill>
                   <a:srgbClr val="FFFFFF"/>
                 </a:solidFill>
@@ -12647,7 +12647,7 @@
               </a:spcAft>
             </a:pPr>
             <a:r>
-              <a:rPr sz="730" b="0" i="0">
+              <a:rPr sz="840" b="0" i="0">
                 <a:solidFill>
                   <a:srgbClr val="7E7868"/>
                 </a:solidFill>
@@ -12664,7 +12664,7 @@
               </a:lnSpc>
             </a:pPr>
             <a:r>
-              <a:rPr sz="1100" b="1" i="0">
+              <a:rPr sz="1260" b="1" i="0">
                 <a:solidFill>
                   <a:srgbClr val="FFFFFF"/>
                 </a:solidFill>
@@ -12681,7 +12681,7 @@
               </a:lnSpc>
             </a:pPr>
             <a:r>
-              <a:rPr sz="1100" b="1" i="0">
+              <a:rPr sz="1260" b="1" i="0">
                 <a:solidFill>
                   <a:srgbClr val="FFFFFF"/>
                 </a:solidFill>
@@ -12701,7 +12701,7 @@
         </p:nvSpPr>
         <p:spPr>
           <a:xfrm>
-            <a:off x="6894000" y="4356000"/>
+            <a:off x="6894000" y="4464000"/>
             <a:ext cx="4197600" cy="14400"/>
           </a:xfrm>
           <a:prstGeom prst="rect">
@@ -12765,7 +12765,7 @@
               </a:lnSpc>
             </a:pPr>
             <a:r>
-              <a:rPr sz="700" b="0" i="0">
+              <a:rPr sz="800" b="0" i="0">
                 <a:solidFill>
                   <a:srgbClr val="8F8A7B"/>
                 </a:solidFill>
@@ -12867,7 +12867,7 @@
               </a:lnSpc>
             </a:pPr>
             <a:r>
-              <a:rPr sz="1050" b="0" i="1" spc="250">
+              <a:rPr sz="1210" b="0" i="1" spc="250">
                 <a:solidFill>
                   <a:srgbClr val="8A6A32"/>
                 </a:solidFill>
@@ -12932,7 +12932,7 @@
         <p:spPr>
           <a:xfrm>
             <a:off x="738000" y="1008000"/>
-            <a:ext cx="10713600" cy="576000"/>
+            <a:ext cx="10713600" cy="666000"/>
           </a:xfrm>
           <a:prstGeom prst="rect">
             <a:avLst/>
@@ -12951,7 +12951,7 @@
               </a:lnSpc>
             </a:pPr>
             <a:r>
-              <a:rPr sz="2900" b="1" i="0" spc="100">
+              <a:rPr sz="3329" b="1" i="0" spc="100">
                 <a:solidFill>
                   <a:srgbClr val="201C15"/>
                 </a:solidFill>
@@ -12961,7 +12961,7 @@
               <a:t>求職者は、</a:t>
             </a:r>
             <a:r>
-              <a:rPr sz="2900" b="1" i="0" spc="100">
+              <a:rPr sz="3329" b="1" i="0" spc="100">
                 <a:solidFill>
                   <a:srgbClr val="B8934E"/>
                 </a:solidFill>
@@ -12971,7 +12971,7 @@
               <a:t>“担当者”</a:t>
             </a:r>
             <a:r>
-              <a:rPr sz="2900" b="1" i="0" spc="100">
+              <a:rPr sz="3329" b="1" i="0" spc="100">
                 <a:solidFill>
                   <a:srgbClr val="201C15"/>
                 </a:solidFill>
@@ -13011,7 +13011,7 @@
               </a:lnSpc>
             </a:pPr>
             <a:r>
-              <a:rPr sz="4400" b="0" i="0">
+              <a:rPr sz="5060" b="0" i="0">
                 <a:solidFill>
                   <a:srgbClr val="201C15"/>
                 </a:solidFill>
@@ -13021,7 +13021,7 @@
               <a:t>36</a:t>
             </a:r>
             <a:r>
-              <a:rPr sz="1600" b="1" i="0">
+              <a:rPr sz="1839" b="1" i="0">
                 <a:solidFill>
                   <a:srgbClr val="201C15"/>
                 </a:solidFill>
@@ -13105,7 +13105,7 @@
               </a:lnSpc>
             </a:pPr>
             <a:r>
-              <a:rPr sz="750" b="0" i="0">
+              <a:rPr sz="860" b="0" i="0">
                 <a:solidFill>
                   <a:srgbClr val="8F8A7B"/>
                 </a:solidFill>
@@ -13145,7 +13145,7 @@
               </a:lnSpc>
             </a:pPr>
             <a:r>
-              <a:rPr sz="4400" b="0" i="0">
+              <a:rPr sz="5060" b="0" i="0">
                 <a:solidFill>
                   <a:srgbClr val="201C15"/>
                 </a:solidFill>
@@ -13155,7 +13155,7 @@
               <a:t>4.2</a:t>
             </a:r>
             <a:r>
-              <a:rPr sz="1600" b="1" i="0">
+              <a:rPr sz="1839" b="1" i="0">
                 <a:solidFill>
                   <a:srgbClr val="201C15"/>
                 </a:solidFill>
@@ -13239,7 +13239,7 @@
               </a:lnSpc>
             </a:pPr>
             <a:r>
-              <a:rPr sz="750" b="0" i="0">
+              <a:rPr sz="860" b="0" i="0">
                 <a:solidFill>
                   <a:srgbClr val="8F8A7B"/>
                 </a:solidFill>
@@ -13326,7 +13326,7 @@
               </a:spcAft>
             </a:pPr>
             <a:r>
-              <a:rPr sz="1150" b="1" i="0">
+              <a:rPr sz="1320" b="1" i="0">
                 <a:solidFill>
                   <a:srgbClr val="201C15"/>
                 </a:solidFill>
@@ -13343,7 +13343,7 @@
               </a:lnSpc>
             </a:pPr>
             <a:r>
-              <a:rPr sz="880" b="0" i="0">
+              <a:rPr sz="1010" b="0" i="0">
                 <a:solidFill>
                   <a:srgbClr val="201C15"/>
                 </a:solidFill>
@@ -13360,7 +13360,7 @@
               </a:lnSpc>
             </a:pPr>
             <a:r>
-              <a:rPr sz="880" b="0" i="0">
+              <a:rPr sz="1010" b="0" i="0">
                 <a:solidFill>
                   <a:srgbClr val="201C15"/>
                 </a:solidFill>
@@ -13377,7 +13377,7 @@
               </a:lnSpc>
             </a:pPr>
             <a:r>
-              <a:rPr sz="880" b="0" i="0">
+              <a:rPr sz="1010" b="0" i="0">
                 <a:solidFill>
                   <a:srgbClr val="201C15"/>
                 </a:solidFill>
@@ -13464,7 +13464,7 @@
               </a:spcAft>
             </a:pPr>
             <a:r>
-              <a:rPr sz="750" b="0" i="0" spc="200">
+              <a:rPr sz="860" b="0" i="0" spc="200">
                 <a:solidFill>
                   <a:srgbClr val="D8C08C"/>
                 </a:solidFill>
@@ -13481,7 +13481,7 @@
               </a:lnSpc>
             </a:pPr>
             <a:r>
-              <a:rPr sz="1000" b="1" i="0">
+              <a:rPr sz="1150" b="1" i="0">
                 <a:solidFill>
                   <a:srgbClr val="FFFFFF"/>
                 </a:solidFill>
@@ -13521,7 +13521,7 @@
               </a:lnSpc>
             </a:pPr>
             <a:r>
-              <a:rPr sz="700" b="0" i="0">
+              <a:rPr sz="800" b="0" i="0">
                 <a:solidFill>
                   <a:srgbClr val="8F8A7B"/>
                 </a:solidFill>
@@ -13667,7 +13667,7 @@
               </a:lnSpc>
             </a:pPr>
             <a:r>
-              <a:rPr sz="1050" b="0" i="1" spc="250">
+              <a:rPr sz="1210" b="0" i="1" spc="250">
                 <a:solidFill>
                   <a:srgbClr val="D8C08C"/>
                 </a:solidFill>
@@ -13751,14 +13751,14 @@
               </a:lnSpc>
             </a:pPr>
             <a:r>
-              <a:rPr sz="2700" b="1" i="0" spc="100">
+              <a:rPr sz="3100" b="1" i="0" spc="100">
                 <a:solidFill>
                   <a:srgbClr val="FFFFFF"/>
                 </a:solidFill>
                 <a:latin typeface="Garamond"/>
                 <a:ea typeface="游明朝"/>
               </a:rPr>
-              <a:t>送り手を絞ることで、</a:t>
+              <a:t>“送る”のをやめて、</a:t>
             </a:r>
           </a:p>
           <a:p>
@@ -13768,7 +13768,7 @@
               </a:lnSpc>
             </a:pPr>
             <a:r>
-              <a:rPr sz="2700" b="1" i="0">
+              <a:rPr sz="3100" b="1" i="0">
                 <a:solidFill>
                   <a:srgbClr val="FFFFFF"/>
                 </a:solidFill>
@@ -13778,24 +13778,24 @@
               <a:t>“</a:t>
             </a:r>
             <a:r>
-              <a:rPr sz="2700" b="1" i="0">
+              <a:rPr sz="3100" b="1" i="0">
                 <a:solidFill>
                   <a:srgbClr val="D8C08C"/>
                 </a:solidFill>
                 <a:latin typeface="Garamond"/>
                 <a:ea typeface="游明朝"/>
               </a:rPr>
-              <a:t>届く</a:t>
-            </a:r>
-            <a:r>
-              <a:rPr sz="2700" b="1" i="0">
+              <a:t>選ばれる</a:t>
+            </a:r>
+            <a:r>
+              <a:rPr sz="3100" b="1" i="0">
                 <a:solidFill>
                   <a:srgbClr val="FFFFFF"/>
                 </a:solidFill>
                 <a:latin typeface="Garamond"/>
                 <a:ea typeface="游明朝"/>
               </a:rPr>
-              <a:t>”を取り戻す。</a:t>
+              <a:t>”へ。</a:t>
             </a:r>
           </a:p>
         </p:txBody>
@@ -13828,7 +13828,7 @@
               </a:lnSpc>
             </a:pPr>
             <a:r>
-              <a:rPr sz="1400" b="0" i="0">
+              <a:rPr sz="1610" b="0" i="0">
                 <a:solidFill>
                   <a:srgbClr val="FFFFFF"/>
                 </a:solidFill>
@@ -13838,7 +13838,7 @@
               <a:t>MarkGate</a:t>
             </a:r>
             <a:r>
-              <a:rPr sz="1400" b="0" i="0">
+              <a:rPr sz="1610" b="0" i="0">
                 <a:solidFill>
                   <a:srgbClr val="B8934E"/>
                 </a:solidFill>
@@ -13848,14 +13848,14 @@
               <a:t>.</a:t>
             </a:r>
             <a:r>
-              <a:rPr sz="1000" b="0" i="0" spc="200">
+              <a:rPr sz="1150" b="0" i="0" spc="200">
                 <a:solidFill>
                   <a:srgbClr val="ABA595"/>
                 </a:solidFill>
                 <a:latin typeface="Yu Gothic"/>
                 <a:ea typeface="游ゴシック"/>
               </a:rPr>
-              <a:t>　— 審査制 × 届くスカウト × 指名</a:t>
+              <a:t>　— 審査制 × 指名</a:t>
             </a:r>
           </a:p>
         </p:txBody>
@@ -13932,7 +13932,7 @@
               </a:lnSpc>
             </a:pPr>
             <a:r>
-              <a:rPr sz="1900" b="0" i="1">
+              <a:rPr sz="2180" b="0" i="1">
                 <a:solidFill>
                   <a:srgbClr val="D8C08C"/>
                 </a:solidFill>
@@ -13972,7 +13972,7 @@
               </a:lnSpc>
             </a:pPr>
             <a:r>
-              <a:rPr sz="930" b="0" i="0">
+              <a:rPr sz="1070" b="0" i="0">
                 <a:solidFill>
                   <a:srgbClr val="ABA595"/>
                 </a:solidFill>
@@ -14056,14 +14056,14 @@
               </a:lnSpc>
             </a:pPr>
             <a:r>
-              <a:rPr sz="1900" b="0" i="1">
+              <a:rPr sz="2180" b="0" i="1">
                 <a:solidFill>
                   <a:srgbClr val="D8C08C"/>
                 </a:solidFill>
                 <a:latin typeface="Garamond"/>
                 <a:ea typeface="游明朝"/>
               </a:rPr>
-              <a:t>Reach</a:t>
+              <a:t>Choice</a:t>
             </a:r>
           </a:p>
         </p:txBody>
@@ -14096,14 +14096,14 @@
               </a:lnSpc>
             </a:pPr>
             <a:r>
-              <a:rPr sz="930" b="0" i="0">
+              <a:rPr sz="1070" b="0" i="0">
                 <a:solidFill>
                   <a:srgbClr val="ABA595"/>
                 </a:solidFill>
                 <a:latin typeface="Yu Gothic"/>
                 <a:ea typeface="游ゴシック"/>
               </a:rPr>
-              <a:t>送信総量が絞られるから、1通が埋もれない。返信率を構造で高める設計。</a:t>
+              <a:t>求職者が実績・専門領域を見て、相談相手を自分で選び、指名する。</a:t>
             </a:r>
           </a:p>
         </p:txBody>
@@ -14180,14 +14180,14 @@
               </a:lnSpc>
             </a:pPr>
             <a:r>
-              <a:rPr sz="1900" b="0" i="1">
+              <a:rPr sz="2180" b="0" i="1">
                 <a:solidFill>
                   <a:srgbClr val="D8C08C"/>
                 </a:solidFill>
                 <a:latin typeface="Garamond"/>
                 <a:ea typeface="游明朝"/>
               </a:rPr>
-              <a:t>Choice</a:t>
+              <a:t>Trust</a:t>
             </a:r>
           </a:p>
         </p:txBody>
@@ -14220,14 +14220,14 @@
               </a:lnSpc>
             </a:pPr>
             <a:r>
-              <a:rPr sz="930" b="0" i="0">
+              <a:rPr sz="1070" b="0" i="0">
                 <a:solidFill>
                   <a:srgbClr val="ABA595"/>
                 </a:solidFill>
                 <a:latin typeface="Yu Gothic"/>
                 <a:ea typeface="游ゴシック"/>
               </a:rPr>
-              <a:t>求職者からの指名も届く。攻めと受け、双方向のマッチング。</a:t>
+              <a:t>選ばれて始まる面談だから、温度が高い。辞退や音信不通が起きにくい。</a:t>
             </a:r>
           </a:p>
         </p:txBody>
@@ -14366,7 +14366,7 @@
               </a:lnSpc>
             </a:pPr>
             <a:r>
-              <a:rPr sz="1050" b="0" i="1" spc="250">
+              <a:rPr sz="1210" b="0" i="1" spc="250">
                 <a:solidFill>
                   <a:srgbClr val="8A6A32"/>
                 </a:solidFill>
@@ -14431,7 +14431,7 @@
         <p:spPr>
           <a:xfrm>
             <a:off x="738000" y="1008000"/>
-            <a:ext cx="10713600" cy="576000"/>
+            <a:ext cx="10713600" cy="666000"/>
           </a:xfrm>
           <a:prstGeom prst="rect">
             <a:avLst/>
@@ -14450,7 +14450,7 @@
               </a:lnSpc>
             </a:pPr>
             <a:r>
-              <a:rPr sz="2900" b="1" i="0" spc="100">
+              <a:rPr sz="3329" b="1" i="0" spc="100">
                 <a:solidFill>
                   <a:srgbClr val="201C15"/>
                 </a:solidFill>
@@ -14460,7 +14460,7 @@
               <a:t>求職者が、CAを</a:t>
             </a:r>
             <a:r>
-              <a:rPr sz="2900" b="1" i="0" spc="100">
+              <a:rPr sz="3329" b="1" i="0" spc="100">
                 <a:solidFill>
                   <a:srgbClr val="B8934E"/>
                 </a:solidFill>
@@ -14470,7 +14470,7 @@
               <a:t>“指名”</a:t>
             </a:r>
             <a:r>
-              <a:rPr sz="2900" b="1" i="0" spc="100">
+              <a:rPr sz="3329" b="1" i="0" spc="100">
                 <a:solidFill>
                   <a:srgbClr val="201C15"/>
                 </a:solidFill>
@@ -14490,7 +14490,7 @@
         </p:nvSpPr>
         <p:spPr>
           <a:xfrm>
-            <a:off x="738000" y="1602000"/>
+            <a:off x="738000" y="1692000"/>
             <a:ext cx="10713600" cy="324000"/>
           </a:xfrm>
           <a:prstGeom prst="rect">
@@ -14510,7 +14510,7 @@
               </a:lnSpc>
             </a:pPr>
             <a:r>
-              <a:rPr sz="1050" b="0" i="0" spc="100">
+              <a:rPr sz="1210" b="0" i="0" spc="100">
                 <a:solidFill>
                   <a:srgbClr val="8F8A7B"/>
                 </a:solidFill>
@@ -14641,7 +14641,7 @@
               </a:spcAft>
             </a:pPr>
             <a:r>
-              <a:rPr sz="850" b="0" i="1" spc="200">
+              <a:rPr sz="980" b="0" i="1" spc="200">
                 <a:solidFill>
                   <a:srgbClr val="8A6A32"/>
                 </a:solidFill>
@@ -14661,7 +14661,7 @@
               </a:spcAft>
             </a:pPr>
             <a:r>
-              <a:rPr sz="1100" b="0" i="1">
+              <a:rPr sz="1260" b="0" i="1">
                 <a:solidFill>
                   <a:srgbClr val="8A6A32"/>
                 </a:solidFill>
@@ -14671,7 +14671,7 @@
               <a:t>01　</a:t>
             </a:r>
             <a:r>
-              <a:rPr sz="1000" b="0" i="0">
+              <a:rPr sz="1150" b="0" i="0">
                 <a:solidFill>
                   <a:srgbClr val="201C15"/>
                 </a:solidFill>
@@ -14691,7 +14691,7 @@
               </a:spcAft>
             </a:pPr>
             <a:r>
-              <a:rPr sz="1100" b="0" i="1">
+              <a:rPr sz="1260" b="0" i="1">
                 <a:solidFill>
                   <a:srgbClr val="8A6A32"/>
                 </a:solidFill>
@@ -14701,7 +14701,7 @@
               <a:t>02　</a:t>
             </a:r>
             <a:r>
-              <a:rPr sz="1000" b="0" i="0">
+              <a:rPr sz="1150" b="0" i="0">
                 <a:solidFill>
                   <a:srgbClr val="201C15"/>
                 </a:solidFill>
@@ -14721,7 +14721,7 @@
               </a:spcAft>
             </a:pPr>
             <a:r>
-              <a:rPr sz="1100" b="0" i="1">
+              <a:rPr sz="1260" b="0" i="1">
                 <a:solidFill>
                   <a:srgbClr val="8A6A32"/>
                 </a:solidFill>
@@ -14731,7 +14731,7 @@
               <a:t>03　</a:t>
             </a:r>
             <a:r>
-              <a:rPr sz="1000" b="0" i="0">
+              <a:rPr sz="1150" b="0" i="0">
                 <a:solidFill>
                   <a:srgbClr val="201C15"/>
                 </a:solidFill>
@@ -14771,7 +14771,7 @@
               </a:lnSpc>
             </a:pPr>
             <a:r>
-              <a:rPr sz="1500" b="0" i="0">
+              <a:rPr sz="1720" b="0" i="0">
                 <a:solidFill>
                   <a:srgbClr val="8F8A7B"/>
                 </a:solidFill>
@@ -14858,7 +14858,7 @@
               </a:spcAft>
             </a:pPr>
             <a:r>
-              <a:rPr sz="850" b="0" i="1" spc="200">
+              <a:rPr sz="980" b="0" i="1" spc="200">
                 <a:solidFill>
                   <a:srgbClr val="D8C08C"/>
                 </a:solidFill>
@@ -14875,7 +14875,7 @@
               </a:lnSpc>
             </a:pPr>
             <a:r>
-              <a:rPr sz="1250" b="1" i="0">
+              <a:rPr sz="1440" b="1" i="0">
                 <a:solidFill>
                   <a:srgbClr val="FFFFFF"/>
                 </a:solidFill>
@@ -14895,7 +14895,7 @@
               </a:spcAft>
             </a:pPr>
             <a:r>
-              <a:rPr sz="1250" b="1" i="0">
+              <a:rPr sz="1440" b="1" i="0">
                 <a:solidFill>
                   <a:srgbClr val="FFFFFF"/>
                 </a:solidFill>
@@ -14915,7 +14915,7 @@
               </a:spcBef>
             </a:pPr>
             <a:r>
-              <a:rPr sz="880" b="0" i="0">
+              <a:rPr sz="1010" b="0" i="0">
                 <a:solidFill>
                   <a:srgbClr val="ABA595"/>
                 </a:solidFill>
@@ -15043,7 +15043,7 @@
               </a:lnSpc>
             </a:pPr>
             <a:r>
-              <a:rPr sz="1050" b="0" i="0">
+              <a:rPr sz="1210" b="0" i="0">
                 <a:solidFill>
                   <a:srgbClr val="FFFFFF"/>
                 </a:solidFill>
@@ -15053,7 +15053,7 @@
               <a:t>プロフィールは貴社の資産 — </a:t>
             </a:r>
             <a:r>
-              <a:rPr sz="1050" b="1" i="0">
+              <a:rPr sz="1210" b="1" i="0">
                 <a:solidFill>
                   <a:srgbClr val="D8C08C"/>
                 </a:solidFill>
@@ -15155,7 +15155,7 @@
               </a:lnSpc>
             </a:pPr>
             <a:r>
-              <a:rPr sz="1050" b="0" i="1" spc="250">
+              <a:rPr sz="1210" b="0" i="1" spc="250">
                 <a:solidFill>
                   <a:srgbClr val="8A6A32"/>
                 </a:solidFill>
@@ -15220,7 +15220,7 @@
         <p:spPr>
           <a:xfrm>
             <a:off x="738000" y="1008000"/>
-            <a:ext cx="10713600" cy="576000"/>
+            <a:ext cx="10713600" cy="666000"/>
           </a:xfrm>
           <a:prstGeom prst="rect">
             <a:avLst/>
@@ -15239,7 +15239,7 @@
               </a:lnSpc>
             </a:pPr>
             <a:r>
-              <a:rPr sz="2900" b="1" i="0" spc="100">
+              <a:rPr sz="3329" b="1" i="0" spc="100">
                 <a:solidFill>
                   <a:srgbClr val="201C15"/>
                 </a:solidFill>
@@ -15249,7 +15249,7 @@
               <a:t>仕組み — 貴社の業務は、</a:t>
             </a:r>
             <a:r>
-              <a:rPr sz="2900" b="1" i="0" spc="100">
+              <a:rPr sz="3329" b="1" i="0" spc="100">
                 <a:solidFill>
                   <a:srgbClr val="B8934E"/>
                 </a:solidFill>
@@ -15259,7 +15259,7 @@
               <a:t>これまで通り</a:t>
             </a:r>
             <a:r>
-              <a:rPr sz="2900" b="1" i="0" spc="100">
+              <a:rPr sz="3329" b="1" i="0" spc="100">
                 <a:solidFill>
                   <a:srgbClr val="201C15"/>
                 </a:solidFill>
@@ -15343,7 +15343,7 @@
               </a:lnSpc>
             </a:pPr>
             <a:r>
-              <a:rPr sz="1500" b="0" i="1">
+              <a:rPr sz="1720" b="0" i="1">
                 <a:solidFill>
                   <a:srgbClr val="8A6A32"/>
                 </a:solidFill>
@@ -15383,7 +15383,7 @@
               </a:lnSpc>
             </a:pPr>
             <a:r>
-              <a:rPr sz="1250" b="1" i="0">
+              <a:rPr sz="1440" b="1" i="0">
                 <a:solidFill>
                   <a:srgbClr val="201C15"/>
                 </a:solidFill>
@@ -15423,7 +15423,7 @@
               </a:lnSpc>
             </a:pPr>
             <a:r>
-              <a:rPr sz="930" b="0" i="0">
+              <a:rPr sz="1070" b="0" i="0">
                 <a:solidFill>
                   <a:srgbClr val="201C15"/>
                 </a:solidFill>
@@ -15507,7 +15507,7 @@
               </a:lnSpc>
             </a:pPr>
             <a:r>
-              <a:rPr sz="1500" b="0" i="1">
+              <a:rPr sz="1720" b="0" i="1">
                 <a:solidFill>
                   <a:srgbClr val="8A6A32"/>
                 </a:solidFill>
@@ -15547,7 +15547,7 @@
               </a:lnSpc>
             </a:pPr>
             <a:r>
-              <a:rPr sz="1250" b="1" i="0">
+              <a:rPr sz="1440" b="1" i="0">
                 <a:solidFill>
                   <a:srgbClr val="201C15"/>
                 </a:solidFill>
@@ -15587,7 +15587,7 @@
               </a:lnSpc>
             </a:pPr>
             <a:r>
-              <a:rPr sz="930" b="0" i="0">
+              <a:rPr sz="1070" b="0" i="0">
                 <a:solidFill>
                   <a:srgbClr val="201C15"/>
                 </a:solidFill>
@@ -15671,7 +15671,7 @@
               </a:lnSpc>
             </a:pPr>
             <a:r>
-              <a:rPr sz="1500" b="0" i="1">
+              <a:rPr sz="1720" b="0" i="1">
                 <a:solidFill>
                   <a:srgbClr val="8A6A32"/>
                 </a:solidFill>
@@ -15711,14 +15711,14 @@
               </a:lnSpc>
             </a:pPr>
             <a:r>
-              <a:rPr sz="1250" b="1" i="0">
+              <a:rPr sz="1440" b="1" i="0">
                 <a:solidFill>
                   <a:srgbClr val="201C15"/>
                 </a:solidFill>
                 <a:latin typeface="Yu Gothic"/>
                 <a:ea typeface="游ゴシック"/>
               </a:rPr>
-              <a:t>スカウト &amp; 指名</a:t>
+              <a:t>指名の受信</a:t>
             </a:r>
           </a:p>
         </p:txBody>
@@ -15751,14 +15751,14 @@
               </a:lnSpc>
             </a:pPr>
             <a:r>
-              <a:rPr sz="930" b="0" i="0">
+              <a:rPr sz="1070" b="0" i="0">
                 <a:solidFill>
                   <a:srgbClr val="201C15"/>
                 </a:solidFill>
                 <a:latin typeface="Yu Gothic"/>
                 <a:ea typeface="游ゴシック"/>
               </a:rPr>
-              <a:t>CAからのスカウトも、求職者からの指名も。双方向でつながる。</a:t>
+              <a:t>プロフィールを見た求職者から、指名が届く。</a:t>
             </a:r>
           </a:p>
         </p:txBody>
@@ -15835,7 +15835,7 @@
               </a:lnSpc>
             </a:pPr>
             <a:r>
-              <a:rPr sz="1500" b="0" i="1">
+              <a:rPr sz="1720" b="0" i="1">
                 <a:solidFill>
                   <a:srgbClr val="8A6A32"/>
                 </a:solidFill>
@@ -15875,7 +15875,7 @@
               </a:lnSpc>
             </a:pPr>
             <a:r>
-              <a:rPr sz="1250" b="1" i="0">
+              <a:rPr sz="1440" b="1" i="0">
                 <a:solidFill>
                   <a:srgbClr val="201C15"/>
                 </a:solidFill>
@@ -15915,7 +15915,7 @@
               </a:lnSpc>
             </a:pPr>
             <a:r>
-              <a:rPr sz="930" b="0" i="0">
+              <a:rPr sz="1070" b="0" i="0">
                 <a:solidFill>
                   <a:srgbClr val="201C15"/>
                 </a:solidFill>
@@ -15999,24 +15999,24 @@
               </a:lnSpc>
             </a:pPr>
             <a:r>
-              <a:rPr sz="1050" b="0" i="0">
+              <a:rPr sz="1210" b="0" i="0">
                 <a:solidFill>
                   <a:srgbClr val="FFFFFF"/>
                 </a:solidFill>
                 <a:latin typeface="Yu Gothic"/>
                 <a:ea typeface="游ゴシック"/>
               </a:rPr>
-              <a:t>送り手が絞られているから、1通のスカウトが競争に埋もれない。</a:t>
-            </a:r>
-            <a:r>
-              <a:rPr sz="1050" b="1" i="0">
+              <a:t>掲載して、待つだけ。</a:t>
+            </a:r>
+            <a:r>
+              <a:rPr sz="1210" b="1" i="0">
                 <a:solidFill>
                   <a:srgbClr val="D8C08C"/>
                 </a:solidFill>
                 <a:latin typeface="Yu Gothic"/>
                 <a:ea typeface="游ゴシック"/>
               </a:rPr>
-              <a:t>母集団形成はプラットフォームの仕事です。</a:t>
+              <a:t>母集団形成と指名の創出は、プラットフォームの仕事です。</a:t>
             </a:r>
           </a:p>
         </p:txBody>
@@ -16111,7 +16111,7 @@
               </a:lnSpc>
             </a:pPr>
             <a:r>
-              <a:rPr sz="1050" b="0" i="1" spc="250">
+              <a:rPr sz="1210" b="0" i="1" spc="250">
                 <a:solidFill>
                   <a:srgbClr val="8A6A32"/>
                 </a:solidFill>
@@ -16176,7 +16176,7 @@
         <p:spPr>
           <a:xfrm>
             <a:off x="738000" y="1008000"/>
-            <a:ext cx="10713600" cy="576000"/>
+            <a:ext cx="10713600" cy="666000"/>
           </a:xfrm>
           <a:prstGeom prst="rect">
             <a:avLst/>
@@ -16195,7 +16195,7 @@
               </a:lnSpc>
             </a:pPr>
             <a:r>
-              <a:rPr sz="2900" b="1" i="0" spc="100">
+              <a:rPr sz="3329" b="1" i="0" spc="100">
                 <a:solidFill>
                   <a:srgbClr val="201C15"/>
                 </a:solidFill>
@@ -16205,7 +16205,7 @@
               <a:t>審査は、狭き門ほど、</a:t>
             </a:r>
             <a:r>
-              <a:rPr sz="2900" b="1" i="0" spc="100">
+              <a:rPr sz="3329" b="1" i="0" spc="100">
                 <a:solidFill>
                   <a:srgbClr val="B8934E"/>
                 </a:solidFill>
@@ -16215,7 +16215,7 @@
               <a:t>価値</a:t>
             </a:r>
             <a:r>
-              <a:rPr sz="2900" b="1" i="0" spc="100">
+              <a:rPr sz="3329" b="1" i="0" spc="100">
                 <a:solidFill>
                   <a:srgbClr val="201C15"/>
                 </a:solidFill>
@@ -16235,7 +16235,7 @@
         </p:nvSpPr>
         <p:spPr>
           <a:xfrm>
-            <a:off x="738000" y="1602000"/>
+            <a:off x="738000" y="1692000"/>
             <a:ext cx="10713600" cy="324000"/>
           </a:xfrm>
           <a:prstGeom prst="rect">
@@ -16255,14 +16255,14 @@
               </a:lnSpc>
             </a:pPr>
             <a:r>
-              <a:rPr sz="1050" b="0" i="0" spc="100">
+              <a:rPr sz="1210" b="0" i="0" spc="100">
                 <a:solidFill>
                   <a:srgbClr val="8F8A7B"/>
                 </a:solidFill>
                 <a:latin typeface="Yu Gothic"/>
                 <a:ea typeface="游ゴシック"/>
               </a:rPr>
-              <a:t>「誰でも登録できる場」にしないこと自体が、貴社のスカウトが届く理由です。</a:t>
+              <a:t>「誰でも登録できる場」にしないこと自体が、求職者が安心して“指名”できる理由です。</a:t>
             </a:r>
           </a:p>
         </p:txBody>
@@ -16339,7 +16339,7 @@
               </a:lnSpc>
             </a:pPr>
             <a:r>
-              <a:rPr sz="1200" b="1" i="0">
+              <a:rPr sz="1380" b="1" i="0">
                 <a:solidFill>
                   <a:srgbClr val="201C15"/>
                 </a:solidFill>
@@ -16349,7 +16349,7 @@
               <a:t>実績</a:t>
             </a:r>
             <a:r>
-              <a:rPr sz="700" b="0" i="0" spc="200">
+              <a:rPr sz="800" b="0" i="0" spc="200">
                 <a:solidFill>
                   <a:srgbClr val="8F8A7B"/>
                 </a:solidFill>
@@ -16389,7 +16389,7 @@
               </a:lnSpc>
             </a:pPr>
             <a:r>
-              <a:rPr sz="880" b="0" i="0">
+              <a:rPr sz="1010" b="0" i="0">
                 <a:solidFill>
                   <a:srgbClr val="201C15"/>
                 </a:solidFill>
@@ -16473,7 +16473,7 @@
               </a:lnSpc>
             </a:pPr>
             <a:r>
-              <a:rPr sz="1200" b="1" i="0">
+              <a:rPr sz="1380" b="1" i="0">
                 <a:solidFill>
                   <a:srgbClr val="201C15"/>
                 </a:solidFill>
@@ -16483,7 +16483,7 @@
               <a:t>専門性</a:t>
             </a:r>
             <a:r>
-              <a:rPr sz="700" b="0" i="0" spc="200">
+              <a:rPr sz="800" b="0" i="0" spc="200">
                 <a:solidFill>
                   <a:srgbClr val="8F8A7B"/>
                 </a:solidFill>
@@ -16523,7 +16523,7 @@
               </a:lnSpc>
             </a:pPr>
             <a:r>
-              <a:rPr sz="880" b="0" i="0">
+              <a:rPr sz="1010" b="0" i="0">
                 <a:solidFill>
                   <a:srgbClr val="201C15"/>
                 </a:solidFill>
@@ -16607,7 +16607,7 @@
               </a:lnSpc>
             </a:pPr>
             <a:r>
-              <a:rPr sz="1200" b="1" i="0">
+              <a:rPr sz="1380" b="1" i="0">
                 <a:solidFill>
                   <a:srgbClr val="201C15"/>
                 </a:solidFill>
@@ -16617,7 +16617,7 @@
               <a:t>支援品質</a:t>
             </a:r>
             <a:r>
-              <a:rPr sz="700" b="0" i="0" spc="200">
+              <a:rPr sz="800" b="0" i="0" spc="200">
                 <a:solidFill>
                   <a:srgbClr val="8F8A7B"/>
                 </a:solidFill>
@@ -16657,7 +16657,7 @@
               </a:lnSpc>
             </a:pPr>
             <a:r>
-              <a:rPr sz="880" b="0" i="0">
+              <a:rPr sz="1010" b="0" i="0">
                 <a:solidFill>
                   <a:srgbClr val="201C15"/>
                 </a:solidFill>
@@ -16744,7 +16744,7 @@
               </a:spcAft>
             </a:pPr>
             <a:r>
-              <a:rPr sz="1500" b="0" i="1">
+              <a:rPr sz="1720" b="0" i="1">
                 <a:solidFill>
                   <a:srgbClr val="D8C08C"/>
                 </a:solidFill>
@@ -16764,7 +16764,7 @@
               </a:spcAft>
             </a:pPr>
             <a:r>
-              <a:rPr sz="1050" b="1" i="0">
+              <a:rPr sz="1210" b="1" i="0">
                 <a:solidFill>
                   <a:srgbClr val="FFFFFF"/>
                 </a:solidFill>
@@ -16784,7 +16784,7 @@
               </a:spcAft>
             </a:pPr>
             <a:r>
-              <a:rPr sz="900" b="0" i="0">
+              <a:rPr sz="1030" b="0" i="0">
                 <a:solidFill>
                   <a:srgbClr val="D8C08C"/>
                 </a:solidFill>
@@ -16794,7 +16794,7 @@
               <a:t>◎　</a:t>
             </a:r>
             <a:r>
-              <a:rPr sz="900" b="0" i="0">
+              <a:rPr sz="1030" b="0" i="0">
                 <a:solidFill>
                   <a:srgbClr val="FFFFFF"/>
                 </a:solidFill>
@@ -16814,7 +16814,7 @@
               </a:spcAft>
             </a:pPr>
             <a:r>
-              <a:rPr sz="900" b="0" i="0">
+              <a:rPr sz="1030" b="0" i="0">
                 <a:solidFill>
                   <a:srgbClr val="D8C08C"/>
                 </a:solidFill>
@@ -16824,7 +16824,7 @@
               <a:t>◎　</a:t>
             </a:r>
             <a:r>
-              <a:rPr sz="900" b="0" i="0">
+              <a:rPr sz="1030" b="0" i="0">
                 <a:solidFill>
                   <a:srgbClr val="FFFFFF"/>
                 </a:solidFill>
@@ -16844,7 +16844,7 @@
               </a:spcAft>
             </a:pPr>
             <a:r>
-              <a:rPr sz="900" b="0" i="0">
+              <a:rPr sz="1030" b="0" i="0">
                 <a:solidFill>
                   <a:srgbClr val="D8C08C"/>
                 </a:solidFill>
@@ -16854,7 +16854,7 @@
               <a:t>◎　</a:t>
             </a:r>
             <a:r>
-              <a:rPr sz="900" b="0" i="0">
+              <a:rPr sz="1030" b="0" i="0">
                 <a:solidFill>
                   <a:srgbClr val="FFFFFF"/>
                 </a:solidFill>
@@ -16874,7 +16874,7 @@
               </a:spcBef>
             </a:pPr>
             <a:r>
-              <a:rPr sz="680" b="0" i="0">
+              <a:rPr sz="780" b="0" i="0">
                 <a:solidFill>
                   <a:srgbClr val="7E7868"/>
                 </a:solidFill>
@@ -16958,7 +16958,7 @@
               </a:lnSpc>
             </a:pPr>
             <a:r>
-              <a:rPr sz="1050" b="0" i="0">
+              <a:rPr sz="1210" b="0" i="0">
                 <a:solidFill>
                   <a:srgbClr val="FFFFFF"/>
                 </a:solidFill>
@@ -16968,7 +16968,7 @@
               <a:t>審査があるから — </a:t>
             </a:r>
             <a:r>
-              <a:rPr sz="1050" b="1" i="0">
+              <a:rPr sz="1210" b="1" i="0">
                 <a:solidFill>
                   <a:srgbClr val="D8C08C"/>
                 </a:solidFill>
@@ -17070,7 +17070,7 @@
               </a:lnSpc>
             </a:pPr>
             <a:r>
-              <a:rPr sz="1050" b="0" i="1" spc="250">
+              <a:rPr sz="1210" b="0" i="1" spc="250">
                 <a:solidFill>
                   <a:srgbClr val="8A6A32"/>
                 </a:solidFill>
@@ -17135,7 +17135,7 @@
         <p:spPr>
           <a:xfrm>
             <a:off x="738000" y="1008000"/>
-            <a:ext cx="10713600" cy="576000"/>
+            <a:ext cx="10713600" cy="666000"/>
           </a:xfrm>
           <a:prstGeom prst="rect">
             <a:avLst/>
@@ -17154,17 +17154,17 @@
               </a:lnSpc>
             </a:pPr>
             <a:r>
-              <a:rPr sz="2900" b="1" i="0" spc="100">
+              <a:rPr sz="3329" b="1" i="0" spc="100">
                 <a:solidFill>
                   <a:srgbClr val="201C15"/>
                 </a:solidFill>
                 <a:latin typeface="Garamond"/>
                 <a:ea typeface="游明朝"/>
               </a:rPr>
-              <a:t>“送る仕事”を、減らす</a:t>
-            </a:r>
-            <a:r>
-              <a:rPr sz="2900" b="1" i="0" spc="100">
+              <a:t>“送る仕事”を、なくす</a:t>
+            </a:r>
+            <a:r>
+              <a:rPr sz="3329" b="1" i="0" spc="100">
                 <a:solidFill>
                   <a:srgbClr val="B8934E"/>
                 </a:solidFill>
@@ -17174,7 +17174,7 @@
               <a:t>構造</a:t>
             </a:r>
             <a:r>
-              <a:rPr sz="2900" b="1" i="0" spc="100">
+              <a:rPr sz="3329" b="1" i="0" spc="100">
                 <a:solidFill>
                   <a:srgbClr val="201C15"/>
                 </a:solidFill>
@@ -17194,7 +17194,7 @@
         </p:nvSpPr>
         <p:spPr>
           <a:xfrm>
-            <a:off x="738000" y="1602000"/>
+            <a:off x="738000" y="1692000"/>
             <a:ext cx="10713600" cy="324000"/>
           </a:xfrm>
           <a:prstGeom prst="rect">
@@ -17214,7 +17214,7 @@
               </a:lnSpc>
             </a:pPr>
             <a:r>
-              <a:rPr sz="1050" b="0" i="0" spc="100">
+              <a:rPr sz="1210" b="0" i="0" spc="100">
                 <a:solidFill>
                   <a:srgbClr val="8F8A7B"/>
                 </a:solidFill>
@@ -17298,7 +17298,7 @@
               </a:lnSpc>
             </a:pPr>
             <a:r>
-              <a:rPr sz="1500" b="0" i="1">
+              <a:rPr sz="1720" b="0" i="1">
                 <a:solidFill>
                   <a:srgbClr val="8A6A32"/>
                 </a:solidFill>
@@ -17338,14 +17338,14 @@
               </a:lnSpc>
             </a:pPr>
             <a:r>
-              <a:rPr sz="1200" b="1" i="0">
+              <a:rPr sz="1380" b="1" i="0">
                 <a:solidFill>
                   <a:srgbClr val="201C15"/>
                 </a:solidFill>
                 <a:latin typeface="Yu Gothic"/>
                 <a:ea typeface="游ゴシック"/>
               </a:rPr>
-              <a:t>大量送信が、前提でなくなる</a:t>
+              <a:t>送る工数が、ゼロになる</a:t>
             </a:r>
           </a:p>
         </p:txBody>
@@ -17378,14 +17378,14 @@
               </a:lnSpc>
             </a:pPr>
             <a:r>
-              <a:rPr sz="930" b="0" i="0">
+              <a:rPr sz="1070" b="0" i="0">
                 <a:solidFill>
                   <a:srgbClr val="201C15"/>
                 </a:solidFill>
                 <a:latin typeface="Yu Gothic"/>
                 <a:ea typeface="游ゴシック"/>
               </a:rPr>
-              <a:t>送り手が絞られた場では、埋もれ対策の“数打ち”が要らない。読まれる前提で、1通に時間を使えます。</a:t>
+              <a:t>指名は“待って受け取る”接点。スカウト送信や文面作成の工数そのものが発生しません。</a:t>
             </a:r>
           </a:p>
         </p:txBody>
@@ -17462,7 +17462,7 @@
               </a:lnSpc>
             </a:pPr>
             <a:r>
-              <a:rPr sz="1500" b="0" i="1">
+              <a:rPr sz="1720" b="0" i="1">
                 <a:solidFill>
                   <a:srgbClr val="8A6A32"/>
                 </a:solidFill>
@@ -17502,7 +17502,7 @@
               </a:lnSpc>
             </a:pPr>
             <a:r>
-              <a:rPr sz="1200" b="1" i="0">
+              <a:rPr sz="1380" b="1" i="0">
                 <a:solidFill>
                   <a:srgbClr val="201C15"/>
                 </a:solidFill>
@@ -17542,7 +17542,7 @@
               </a:lnSpc>
             </a:pPr>
             <a:r>
-              <a:rPr sz="930" b="0" i="0">
+              <a:rPr sz="1070" b="0" i="0">
                 <a:solidFill>
                   <a:srgbClr val="201C15"/>
                 </a:solidFill>
@@ -17626,7 +17626,7 @@
               </a:lnSpc>
             </a:pPr>
             <a:r>
-              <a:rPr sz="1500" b="0" i="1">
+              <a:rPr sz="1720" b="0" i="1">
                 <a:solidFill>
                   <a:srgbClr val="8A6A32"/>
                 </a:solidFill>
@@ -17666,7 +17666,7 @@
               </a:lnSpc>
             </a:pPr>
             <a:r>
-              <a:rPr sz="1200" b="1" i="0">
+              <a:rPr sz="1380" b="1" i="0">
                 <a:solidFill>
                   <a:srgbClr val="201C15"/>
                 </a:solidFill>
@@ -17706,7 +17706,7 @@
               </a:lnSpc>
             </a:pPr>
             <a:r>
-              <a:rPr sz="930" b="0" i="0">
+              <a:rPr sz="1070" b="0" i="0">
                 <a:solidFill>
                   <a:srgbClr val="201C15"/>
                 </a:solidFill>
@@ -17790,7 +17790,7 @@
               </a:lnSpc>
             </a:pPr>
             <a:r>
-              <a:rPr sz="1050" b="0" i="0">
+              <a:rPr sz="1210" b="0" i="0">
                 <a:solidFill>
                   <a:srgbClr val="FFFFFF"/>
                 </a:solidFill>
@@ -17800,7 +17800,7 @@
               <a:t>送信に使っていた時間を、面談と支援へ。</a:t>
             </a:r>
             <a:r>
-              <a:rPr sz="1050" b="1" i="0">
+              <a:rPr sz="1210" b="1" i="0">
                 <a:solidFill>
                   <a:srgbClr val="D8C08C"/>
                 </a:solidFill>

</xml_diff>